<commit_message>
feat: rebuild poster PPT matching exact template layout and colors
</commit_message>
<xml_diff>
--- a/poster.pptx
+++ b/poster.pptx
@@ -3097,7 +3097,7 @@
         <p:spPr>
           <a:xfrm>
             <a:off x="0" y="0"/>
-            <a:ext cx="18288000" cy="1371600"/>
+            <a:ext cx="18288000" cy="1335024"/>
           </a:xfrm>
           <a:prstGeom prst="rect">
             <a:avLst/>
@@ -3139,8 +3139,51 @@
         </p:nvSpPr>
         <p:spPr>
           <a:xfrm>
-            <a:off x="0" y="1344168"/>
-            <a:ext cx="18288000" cy="45720"/>
+            <a:off x="0" y="1371600"/>
+            <a:ext cx="5120640" cy="8275320"/>
+          </a:xfrm>
+          <a:prstGeom prst="rect">
+            <a:avLst/>
+          </a:prstGeom>
+          <a:solidFill>
+            <a:srgbClr val="FFFFFF"/>
+          </a:solidFill>
+          <a:ln>
+            <a:noFill/>
+          </a:ln>
+        </p:spPr>
+        <p:style>
+          <a:lnRef idx="1">
+            <a:schemeClr val="accent1"/>
+          </a:lnRef>
+          <a:fillRef idx="3">
+            <a:schemeClr val="accent1"/>
+          </a:fillRef>
+          <a:effectRef idx="2">
+            <a:schemeClr val="accent1"/>
+          </a:effectRef>
+          <a:fontRef idx="minor">
+            <a:schemeClr val="lt1"/>
+          </a:fontRef>
+        </p:style>
+        <p:txBody>
+          <a:bodyPr rtlCol="0" anchor="ctr"/>
+          <a:lstStyle/>
+          <a:p>
+            <a:pPr algn="ctr"/>
+          </a:p>
+        </p:txBody>
+      </p:sp>
+      <p:sp>
+        <p:nvSpPr>
+          <p:cNvPr id="4" name="Rectangle 3"/>
+          <p:cNvSpPr/>
+          <p:nvPr/>
+        </p:nvSpPr>
+        <p:spPr>
+          <a:xfrm>
+            <a:off x="5166360" y="1371600"/>
+            <a:ext cx="6537960" cy="8275320"/>
           </a:xfrm>
           <a:prstGeom prst="rect">
             <a:avLst/>
@@ -3176,431 +3219,14 @@
       </p:sp>
       <p:sp>
         <p:nvSpPr>
-          <p:cNvPr id="4" name="TextBox 3"/>
-          <p:cNvSpPr txBox="1"/>
-          <p:nvPr/>
-        </p:nvSpPr>
-        <p:spPr>
-          <a:xfrm>
-            <a:off x="182880" y="73152"/>
-            <a:ext cx="4114800" cy="256032"/>
-          </a:xfrm>
-          <a:prstGeom prst="rect">
-            <a:avLst/>
-          </a:prstGeom>
-          <a:noFill/>
-        </p:spPr>
-        <p:txBody>
-          <a:bodyPr wrap="square">
-            <a:spAutoFit/>
-          </a:bodyPr>
-          <a:lstStyle/>
-          <a:p>
-            <a:pPr algn="l"/>
-            <a:r>
-              <a:rPr sz="900" b="1" i="0">
-                <a:solidFill>
-                  <a:srgbClr val="1A1A2E"/>
-                </a:solidFill>
-              </a:rPr>
-              <a:t>MIT SCHOOL OF COMPUTING</a:t>
-            </a:r>
-          </a:p>
-        </p:txBody>
-      </p:sp>
-      <p:sp>
-        <p:nvSpPr>
-          <p:cNvPr id="5" name="TextBox 4"/>
-          <p:cNvSpPr txBox="1"/>
-          <p:nvPr/>
-        </p:nvSpPr>
-        <p:spPr>
-          <a:xfrm>
-            <a:off x="182880" y="301752"/>
-            <a:ext cx="4114800" cy="228600"/>
-          </a:xfrm>
-          <a:prstGeom prst="rect">
-            <a:avLst/>
-          </a:prstGeom>
-          <a:noFill/>
-        </p:spPr>
-        <p:txBody>
-          <a:bodyPr wrap="square">
-            <a:spAutoFit/>
-          </a:bodyPr>
-          <a:lstStyle/>
-          <a:p>
-            <a:pPr algn="l"/>
-            <a:r>
-              <a:rPr sz="800" b="1" i="0">
-                <a:solidFill>
-                  <a:srgbClr val="2E5395"/>
-                </a:solidFill>
-              </a:rPr>
-              <a:t>DEPARTMENT OF INFORMATION TECHNOLOGY</a:t>
-            </a:r>
-          </a:p>
-        </p:txBody>
-      </p:sp>
-      <p:sp>
-        <p:nvSpPr>
-          <p:cNvPr id="6" name="TextBox 5"/>
-          <p:cNvSpPr txBox="1"/>
-          <p:nvPr/>
-        </p:nvSpPr>
-        <p:spPr>
-          <a:xfrm>
-            <a:off x="182880" y="530352"/>
-            <a:ext cx="4114800" cy="201168"/>
-          </a:xfrm>
-          <a:prstGeom prst="rect">
-            <a:avLst/>
-          </a:prstGeom>
-          <a:noFill/>
-        </p:spPr>
-        <p:txBody>
-          <a:bodyPr wrap="square">
-            <a:spAutoFit/>
-          </a:bodyPr>
-          <a:lstStyle/>
-          <a:p>
-            <a:pPr algn="l"/>
-            <a:r>
-              <a:rPr sz="750" b="0" i="0">
-                <a:solidFill>
-                  <a:srgbClr val="1A1A2E"/>
-                </a:solidFill>
-              </a:rPr>
-              <a:t>Class: TY-SMAD  |  Group ID: LYSMAD05</a:t>
-            </a:r>
-          </a:p>
-        </p:txBody>
-      </p:sp>
-      <p:sp>
-        <p:nvSpPr>
-          <p:cNvPr id="7" name="TextBox 6"/>
-          <p:cNvSpPr txBox="1"/>
-          <p:nvPr/>
-        </p:nvSpPr>
-        <p:spPr>
-          <a:xfrm>
-            <a:off x="182880" y="713232"/>
-            <a:ext cx="4114800" cy="201168"/>
-          </a:xfrm>
-          <a:prstGeom prst="rect">
-            <a:avLst/>
-          </a:prstGeom>
-          <a:noFill/>
-        </p:spPr>
-        <p:txBody>
-          <a:bodyPr wrap="square">
-            <a:spAutoFit/>
-          </a:bodyPr>
-          <a:lstStyle/>
-          <a:p>
-            <a:pPr algn="l"/>
-            <a:r>
-              <a:rPr sz="750" b="0" i="0">
-                <a:solidFill>
-                  <a:srgbClr val="1A1A2E"/>
-                </a:solidFill>
-              </a:rPr>
-              <a:t>Guide: Prof. Reetika Kerketta</a:t>
-            </a:r>
-          </a:p>
-        </p:txBody>
-      </p:sp>
-      <p:sp>
-        <p:nvSpPr>
-          <p:cNvPr id="8" name="TextBox 7"/>
-          <p:cNvSpPr txBox="1"/>
-          <p:nvPr/>
-        </p:nvSpPr>
-        <p:spPr>
-          <a:xfrm>
-            <a:off x="182880" y="896112"/>
-            <a:ext cx="4114800" cy="201168"/>
-          </a:xfrm>
-          <a:prstGeom prst="rect">
-            <a:avLst/>
-          </a:prstGeom>
-          <a:noFill/>
-        </p:spPr>
-        <p:txBody>
-          <a:bodyPr wrap="square">
-            <a:spAutoFit/>
-          </a:bodyPr>
-          <a:lstStyle/>
-          <a:p>
-            <a:pPr algn="l"/>
-            <a:r>
-              <a:rPr sz="750" b="0" i="0">
-                <a:solidFill>
-                  <a:srgbClr val="1A1A2E"/>
-                </a:solidFill>
-              </a:rPr>
-              <a:t>Academic Year: 2024–25</a:t>
-            </a:r>
-          </a:p>
-        </p:txBody>
-      </p:sp>
-      <p:sp>
-        <p:nvSpPr>
-          <p:cNvPr id="9" name="TextBox 8"/>
-          <p:cNvSpPr txBox="1"/>
-          <p:nvPr/>
-        </p:nvSpPr>
-        <p:spPr>
-          <a:xfrm>
-            <a:off x="4389120" y="91440"/>
-            <a:ext cx="9509760" cy="502920"/>
-          </a:xfrm>
-          <a:prstGeom prst="rect">
-            <a:avLst/>
-          </a:prstGeom>
-          <a:noFill/>
-        </p:spPr>
-        <p:txBody>
-          <a:bodyPr wrap="square">
-            <a:spAutoFit/>
-          </a:bodyPr>
-          <a:lstStyle/>
-          <a:p>
-            <a:pPr algn="ctr"/>
-            <a:r>
-              <a:rPr sz="2600" b="1" i="0">
-                <a:solidFill>
-                  <a:srgbClr val="1A1A2E"/>
-                </a:solidFill>
-              </a:rPr>
-              <a:t>Multi-Tenant SaaS Platform</a:t>
-            </a:r>
-          </a:p>
-        </p:txBody>
-      </p:sp>
-      <p:sp>
-        <p:nvSpPr>
-          <p:cNvPr id="10" name="TextBox 9"/>
-          <p:cNvSpPr txBox="1"/>
-          <p:nvPr/>
-        </p:nvSpPr>
-        <p:spPr>
-          <a:xfrm>
-            <a:off x="4389120" y="566928"/>
-            <a:ext cx="9509760" cy="256032"/>
-          </a:xfrm>
-          <a:prstGeom prst="rect">
-            <a:avLst/>
-          </a:prstGeom>
-          <a:noFill/>
-        </p:spPr>
-        <p:txBody>
-          <a:bodyPr wrap="square">
-            <a:spAutoFit/>
-          </a:bodyPr>
-          <a:lstStyle/>
-          <a:p>
-            <a:pPr algn="ctr"/>
-            <a:r>
-              <a:rPr sz="1000" b="0" i="1">
-                <a:solidFill>
-                  <a:srgbClr val="2E5395"/>
-                </a:solidFill>
-              </a:rPr>
-              <a:t>One platform. Every business. Only what you need.</a:t>
-            </a:r>
-          </a:p>
-        </p:txBody>
-      </p:sp>
-      <p:sp>
-        <p:nvSpPr>
-          <p:cNvPr id="11" name="TextBox 10"/>
-          <p:cNvSpPr txBox="1"/>
-          <p:nvPr/>
-        </p:nvSpPr>
-        <p:spPr>
-          <a:xfrm>
-            <a:off x="4389120" y="841248"/>
-            <a:ext cx="9509760" cy="256032"/>
-          </a:xfrm>
-          <a:prstGeom prst="rect">
-            <a:avLst/>
-          </a:prstGeom>
-          <a:noFill/>
-        </p:spPr>
-        <p:txBody>
-          <a:bodyPr wrap="square">
-            <a:spAutoFit/>
-          </a:bodyPr>
-          <a:lstStyle/>
-          <a:p>
-            <a:pPr algn="ctr"/>
-            <a:r>
-              <a:rPr sz="850" b="1" i="0">
-                <a:solidFill>
-                  <a:srgbClr val="1A1A2E"/>
-                </a:solidFill>
-              </a:rPr>
-              <a:t>1. Poonawala Ibrahim Hussain     2. Mandhare Varad Vikas     3. Tanmay Sudhir Shinde</a:t>
-            </a:r>
-          </a:p>
-        </p:txBody>
-      </p:sp>
-      <p:sp>
-        <p:nvSpPr>
-          <p:cNvPr id="12" name="TextBox 11"/>
-          <p:cNvSpPr txBox="1"/>
-          <p:nvPr/>
-        </p:nvSpPr>
-        <p:spPr>
-          <a:xfrm>
-            <a:off x="14081760" y="182880"/>
-            <a:ext cx="4023360" cy="228600"/>
-          </a:xfrm>
-          <a:prstGeom prst="rect">
-            <a:avLst/>
-          </a:prstGeom>
-          <a:noFill/>
-        </p:spPr>
-        <p:txBody>
-          <a:bodyPr wrap="square">
-            <a:spAutoFit/>
-          </a:bodyPr>
-          <a:lstStyle/>
-          <a:p>
-            <a:pPr algn="r"/>
-            <a:r>
-              <a:rPr sz="800" b="0" i="0">
-                <a:solidFill>
-                  <a:srgbClr val="1A1A2E"/>
-                </a:solidFill>
-              </a:rPr>
-              <a:t>TY-SMAD  |  2024–25</a:t>
-            </a:r>
-          </a:p>
-        </p:txBody>
-      </p:sp>
-      <p:sp>
-        <p:nvSpPr>
-          <p:cNvPr id="13" name="TextBox 12"/>
-          <p:cNvSpPr txBox="1"/>
-          <p:nvPr/>
-        </p:nvSpPr>
-        <p:spPr>
-          <a:xfrm>
-            <a:off x="14081760" y="411480"/>
-            <a:ext cx="4023360" cy="228600"/>
-          </a:xfrm>
-          <a:prstGeom prst="rect">
-            <a:avLst/>
-          </a:prstGeom>
-          <a:noFill/>
-        </p:spPr>
-        <p:txBody>
-          <a:bodyPr wrap="square">
-            <a:spAutoFit/>
-          </a:bodyPr>
-          <a:lstStyle/>
-          <a:p>
-            <a:pPr algn="r"/>
-            <a:r>
-              <a:rPr sz="800" b="0" i="0">
-                <a:solidFill>
-                  <a:srgbClr val="1A1A2E"/>
-                </a:solidFill>
-              </a:rPr>
-              <a:t>Node.js · React.js · PostgreSQL</a:t>
-            </a:r>
-          </a:p>
-        </p:txBody>
-      </p:sp>
-      <p:sp>
-        <p:nvSpPr>
-          <p:cNvPr id="14" name="TextBox 13"/>
-          <p:cNvSpPr txBox="1"/>
-          <p:nvPr/>
-        </p:nvSpPr>
-        <p:spPr>
-          <a:xfrm>
-            <a:off x="14081760" y="640080"/>
-            <a:ext cx="4023360" cy="228600"/>
-          </a:xfrm>
-          <a:prstGeom prst="rect">
-            <a:avLst/>
-          </a:prstGeom>
-          <a:noFill/>
-        </p:spPr>
-        <p:txBody>
-          <a:bodyPr wrap="square">
-            <a:spAutoFit/>
-          </a:bodyPr>
-          <a:lstStyle/>
-          <a:p>
-            <a:pPr algn="r"/>
-            <a:r>
-              <a:rPr sz="800" b="0" i="0">
-                <a:solidFill>
-                  <a:srgbClr val="1A1A2E"/>
-                </a:solidFill>
-              </a:rPr>
-              <a:t>AWS · JWT · RBAC</a:t>
-            </a:r>
-          </a:p>
-        </p:txBody>
-      </p:sp>
-      <p:sp>
-        <p:nvSpPr>
-          <p:cNvPr id="15" name="Rectangle 14"/>
+          <p:cNvPr id="5" name="Rectangle 4"/>
           <p:cNvSpPr/>
           <p:nvPr/>
         </p:nvSpPr>
         <p:spPr>
           <a:xfrm>
-            <a:off x="0" y="1417320"/>
-            <a:ext cx="3657600" cy="8229600"/>
-          </a:xfrm>
-          <a:prstGeom prst="rect">
-            <a:avLst/>
-          </a:prstGeom>
-          <a:solidFill>
-            <a:srgbClr val="FFFFFF"/>
-          </a:solidFill>
-          <a:ln>
-            <a:noFill/>
-          </a:ln>
-        </p:spPr>
-        <p:style>
-          <a:lnRef idx="1">
-            <a:schemeClr val="accent1"/>
-          </a:lnRef>
-          <a:fillRef idx="3">
-            <a:schemeClr val="accent1"/>
-          </a:fillRef>
-          <a:effectRef idx="2">
-            <a:schemeClr val="accent1"/>
-          </a:effectRef>
-          <a:fontRef idx="minor">
-            <a:schemeClr val="lt1"/>
-          </a:fontRef>
-        </p:style>
-        <p:txBody>
-          <a:bodyPr rtlCol="0" anchor="ctr"/>
-          <a:lstStyle/>
-          <a:p>
-            <a:pPr algn="ctr"/>
-          </a:p>
-        </p:txBody>
-      </p:sp>
-      <p:sp>
-        <p:nvSpPr>
-          <p:cNvPr id="16" name="Rectangle 15"/>
-          <p:cNvSpPr/>
-          <p:nvPr/>
-        </p:nvSpPr>
-        <p:spPr>
-          <a:xfrm>
-            <a:off x="3703320" y="1417320"/>
-            <a:ext cx="7223760" cy="8229600"/>
+            <a:off x="11750040" y="1371600"/>
+            <a:ext cx="6537960" cy="8275320"/>
           </a:xfrm>
           <a:prstGeom prst="rect">
             <a:avLst/>
@@ -3636,14 +3262,143 @@
       </p:sp>
       <p:sp>
         <p:nvSpPr>
-          <p:cNvPr id="17" name="Rectangle 16"/>
+          <p:cNvPr id="6" name="Rectangle 5"/>
           <p:cNvSpPr/>
           <p:nvPr/>
         </p:nvSpPr>
         <p:spPr>
           <a:xfrm>
-            <a:off x="10972800" y="1417320"/>
-            <a:ext cx="7315200" cy="8229600"/>
+            <a:off x="0" y="9674352"/>
+            <a:ext cx="18288000" cy="612648"/>
+          </a:xfrm>
+          <a:prstGeom prst="rect">
+            <a:avLst/>
+          </a:prstGeom>
+          <a:solidFill>
+            <a:srgbClr val="091A29"/>
+          </a:solidFill>
+          <a:ln>
+            <a:noFill/>
+          </a:ln>
+        </p:spPr>
+        <p:style>
+          <a:lnRef idx="1">
+            <a:schemeClr val="accent1"/>
+          </a:lnRef>
+          <a:fillRef idx="3">
+            <a:schemeClr val="accent1"/>
+          </a:fillRef>
+          <a:effectRef idx="2">
+            <a:schemeClr val="accent1"/>
+          </a:effectRef>
+          <a:fontRef idx="minor">
+            <a:schemeClr val="lt1"/>
+          </a:fontRef>
+        </p:style>
+        <p:txBody>
+          <a:bodyPr rtlCol="0" anchor="ctr"/>
+          <a:lstStyle/>
+          <a:p>
+            <a:pPr algn="ctr"/>
+          </a:p>
+        </p:txBody>
+      </p:sp>
+      <p:sp>
+        <p:nvSpPr>
+          <p:cNvPr id="7" name="Rectangle 6"/>
+          <p:cNvSpPr/>
+          <p:nvPr/>
+        </p:nvSpPr>
+        <p:spPr>
+          <a:xfrm>
+            <a:off x="5138928" y="1371600"/>
+            <a:ext cx="27432" cy="8275320"/>
+          </a:xfrm>
+          <a:prstGeom prst="rect">
+            <a:avLst/>
+          </a:prstGeom>
+          <a:solidFill>
+            <a:srgbClr val="1A3A6E"/>
+          </a:solidFill>
+          <a:ln>
+            <a:noFill/>
+          </a:ln>
+        </p:spPr>
+        <p:style>
+          <a:lnRef idx="1">
+            <a:schemeClr val="accent1"/>
+          </a:lnRef>
+          <a:fillRef idx="3">
+            <a:schemeClr val="accent1"/>
+          </a:fillRef>
+          <a:effectRef idx="2">
+            <a:schemeClr val="accent1"/>
+          </a:effectRef>
+          <a:fontRef idx="minor">
+            <a:schemeClr val="lt1"/>
+          </a:fontRef>
+        </p:style>
+        <p:txBody>
+          <a:bodyPr rtlCol="0" anchor="ctr"/>
+          <a:lstStyle/>
+          <a:p>
+            <a:pPr algn="ctr"/>
+          </a:p>
+        </p:txBody>
+      </p:sp>
+      <p:sp>
+        <p:nvSpPr>
+          <p:cNvPr id="8" name="Rectangle 7"/>
+          <p:cNvSpPr/>
+          <p:nvPr/>
+        </p:nvSpPr>
+        <p:spPr>
+          <a:xfrm>
+            <a:off x="11722608" y="1371600"/>
+            <a:ext cx="27432" cy="8275320"/>
+          </a:xfrm>
+          <a:prstGeom prst="rect">
+            <a:avLst/>
+          </a:prstGeom>
+          <a:solidFill>
+            <a:srgbClr val="1A3A6E"/>
+          </a:solidFill>
+          <a:ln>
+            <a:noFill/>
+          </a:ln>
+        </p:spPr>
+        <p:style>
+          <a:lnRef idx="1">
+            <a:schemeClr val="accent1"/>
+          </a:lnRef>
+          <a:fillRef idx="3">
+            <a:schemeClr val="accent1"/>
+          </a:fillRef>
+          <a:effectRef idx="2">
+            <a:schemeClr val="accent1"/>
+          </a:effectRef>
+          <a:fontRef idx="minor">
+            <a:schemeClr val="lt1"/>
+          </a:fontRef>
+        </p:style>
+        <p:txBody>
+          <a:bodyPr rtlCol="0" anchor="ctr"/>
+          <a:lstStyle/>
+          <a:p>
+            <a:pPr algn="ctr"/>
+          </a:p>
+        </p:txBody>
+      </p:sp>
+      <p:sp>
+        <p:nvSpPr>
+          <p:cNvPr id="9" name="Rectangle 8"/>
+          <p:cNvSpPr/>
+          <p:nvPr/>
+        </p:nvSpPr>
+        <p:spPr>
+          <a:xfrm>
+            <a:off x="0" y="1298448"/>
+            <a:ext cx="18288000" cy="36576"/>
           </a:xfrm>
           <a:prstGeom prst="rect">
             <a:avLst/>
@@ -3679,14 +3434,495 @@
       </p:sp>
       <p:sp>
         <p:nvSpPr>
-          <p:cNvPr id="18" name="Rectangle 17"/>
+          <p:cNvPr id="10" name="TextBox 9"/>
+          <p:cNvSpPr txBox="1"/>
+          <p:nvPr/>
+        </p:nvSpPr>
+        <p:spPr>
+          <a:xfrm>
+            <a:off x="182880" y="73152"/>
+            <a:ext cx="4389120" cy="1188720"/>
+          </a:xfrm>
+          <a:prstGeom prst="rect">
+            <a:avLst/>
+          </a:prstGeom>
+          <a:noFill/>
+        </p:spPr>
+        <p:txBody>
+          <a:bodyPr wrap="square">
+            <a:spAutoFit/>
+          </a:bodyPr>
+          <a:lstStyle/>
+          <a:p>
+            <a:pPr algn="l"/>
+            <a:r>
+              <a:rPr sz="950" b="1" i="0">
+                <a:solidFill>
+                  <a:srgbClr val="1A1A2E"/>
+                </a:solidFill>
+              </a:rPr>
+              <a:t>MIT SCHOOL OF COMPUTING</a:t>
+            </a:r>
+          </a:p>
+          <a:p>
+            <a:pPr algn="l"/>
+            <a:r>
+              <a:rPr sz="800" b="1" i="0">
+                <a:solidFill>
+                  <a:srgbClr val="2E5395"/>
+                </a:solidFill>
+              </a:rPr>
+              <a:t>DEPARTMENT OF INFORMATION TECHNOLOGY</a:t>
+            </a:r>
+          </a:p>
+          <a:p>
+            <a:pPr algn="l"/>
+            <a:r>
+              <a:rPr sz="500" b="0" i="0">
+                <a:solidFill>
+                  <a:srgbClr val="1A1A2E"/>
+                </a:solidFill>
+              </a:rPr>
+              <a:t/>
+            </a:r>
+          </a:p>
+          <a:p>
+            <a:pPr algn="l"/>
+            <a:r>
+              <a:rPr sz="750" b="0" i="0">
+                <a:solidFill>
+                  <a:srgbClr val="1A1A2E"/>
+                </a:solidFill>
+              </a:rPr>
+              <a:t>Class: TY-SMAD  |  Group ID: LYSMAD05</a:t>
+            </a:r>
+          </a:p>
+          <a:p>
+            <a:pPr algn="l"/>
+            <a:r>
+              <a:rPr sz="750" b="0" i="0">
+                <a:solidFill>
+                  <a:srgbClr val="1A1A2E"/>
+                </a:solidFill>
+              </a:rPr>
+              <a:t>Guide: Prof. Reetika Kerketta</a:t>
+            </a:r>
+          </a:p>
+          <a:p>
+            <a:pPr algn="l"/>
+            <a:r>
+              <a:rPr sz="750" b="0" i="0">
+                <a:solidFill>
+                  <a:srgbClr val="1A1A2E"/>
+                </a:solidFill>
+              </a:rPr>
+              <a:t>Academic Year: 2024–25</a:t>
+            </a:r>
+          </a:p>
+        </p:txBody>
+      </p:sp>
+      <p:sp>
+        <p:nvSpPr>
+          <p:cNvPr id="11" name="TextBox 10"/>
+          <p:cNvSpPr txBox="1"/>
+          <p:nvPr/>
+        </p:nvSpPr>
+        <p:spPr>
+          <a:xfrm>
+            <a:off x="4572000" y="54864"/>
+            <a:ext cx="9144000" cy="594360"/>
+          </a:xfrm>
+          <a:prstGeom prst="rect">
+            <a:avLst/>
+          </a:prstGeom>
+          <a:noFill/>
+        </p:spPr>
+        <p:txBody>
+          <a:bodyPr wrap="square">
+            <a:spAutoFit/>
+          </a:bodyPr>
+          <a:lstStyle/>
+          <a:p>
+            <a:pPr algn="ctr"/>
+            <a:r>
+              <a:rPr sz="2800" b="1" i="0">
+                <a:solidFill>
+                  <a:srgbClr val="1A1A2E"/>
+                </a:solidFill>
+              </a:rPr>
+              <a:t>Multi-Tenant SaaS Platform</a:t>
+            </a:r>
+          </a:p>
+        </p:txBody>
+      </p:sp>
+      <p:sp>
+        <p:nvSpPr>
+          <p:cNvPr id="12" name="TextBox 11"/>
+          <p:cNvSpPr txBox="1"/>
+          <p:nvPr/>
+        </p:nvSpPr>
+        <p:spPr>
+          <a:xfrm>
+            <a:off x="4572000" y="640080"/>
+            <a:ext cx="9144000" cy="274320"/>
+          </a:xfrm>
+          <a:prstGeom prst="rect">
+            <a:avLst/>
+          </a:prstGeom>
+          <a:noFill/>
+        </p:spPr>
+        <p:txBody>
+          <a:bodyPr wrap="square">
+            <a:spAutoFit/>
+          </a:bodyPr>
+          <a:lstStyle/>
+          <a:p>
+            <a:pPr algn="ctr"/>
+            <a:r>
+              <a:rPr sz="1100" b="0" i="1">
+                <a:solidFill>
+                  <a:srgbClr val="2E5395"/>
+                </a:solidFill>
+              </a:rPr>
+              <a:t>One platform. Every business. Only what you need.</a:t>
+            </a:r>
+          </a:p>
+        </p:txBody>
+      </p:sp>
+      <p:sp>
+        <p:nvSpPr>
+          <p:cNvPr id="13" name="TextBox 12"/>
+          <p:cNvSpPr txBox="1"/>
+          <p:nvPr/>
+        </p:nvSpPr>
+        <p:spPr>
+          <a:xfrm>
+            <a:off x="4572000" y="932688"/>
+            <a:ext cx="9144000" cy="274320"/>
+          </a:xfrm>
+          <a:prstGeom prst="rect">
+            <a:avLst/>
+          </a:prstGeom>
+          <a:noFill/>
+        </p:spPr>
+        <p:txBody>
+          <a:bodyPr wrap="square">
+            <a:spAutoFit/>
+          </a:bodyPr>
+          <a:lstStyle/>
+          <a:p>
+            <a:pPr algn="ctr"/>
+            <a:r>
+              <a:rPr sz="900" b="1" i="0">
+                <a:solidFill>
+                  <a:srgbClr val="1A1A2E"/>
+                </a:solidFill>
+              </a:rPr>
+              <a:t>1. Poonawala Ibrahim Hussain     2. Mandhare Varad Vikas     3. Tanmay Sudhir Shinde</a:t>
+            </a:r>
+          </a:p>
+        </p:txBody>
+      </p:sp>
+      <p:sp>
+        <p:nvSpPr>
+          <p:cNvPr id="14" name="TextBox 13"/>
+          <p:cNvSpPr txBox="1"/>
+          <p:nvPr/>
+        </p:nvSpPr>
+        <p:spPr>
+          <a:xfrm>
+            <a:off x="13898880" y="137160"/>
+            <a:ext cx="4206240" cy="1005840"/>
+          </a:xfrm>
+          <a:prstGeom prst="rect">
+            <a:avLst/>
+          </a:prstGeom>
+          <a:noFill/>
+        </p:spPr>
+        <p:txBody>
+          <a:bodyPr wrap="square">
+            <a:spAutoFit/>
+          </a:bodyPr>
+          <a:lstStyle/>
+          <a:p>
+            <a:pPr algn="r"/>
+            <a:r>
+              <a:rPr sz="800" b="0" i="0">
+                <a:solidFill>
+                  <a:srgbClr val="1A1A2E"/>
+                </a:solidFill>
+              </a:rPr>
+              <a:t>TY-SMAD  |  2024–25</a:t>
+            </a:r>
+          </a:p>
+          <a:p>
+            <a:pPr algn="r"/>
+            <a:r>
+              <a:rPr sz="800" b="0" i="0">
+                <a:solidFill>
+                  <a:srgbClr val="1A1A2E"/>
+                </a:solidFill>
+              </a:rPr>
+              <a:t>Node.js  ·  React.js  ·  PostgreSQL</a:t>
+            </a:r>
+          </a:p>
+          <a:p>
+            <a:pPr algn="r"/>
+            <a:r>
+              <a:rPr sz="800" b="0" i="0">
+                <a:solidFill>
+                  <a:srgbClr val="1A1A2E"/>
+                </a:solidFill>
+              </a:rPr>
+              <a:t>AWS  ·  JWT  ·  RBAC</a:t>
+            </a:r>
+          </a:p>
+        </p:txBody>
+      </p:sp>
+      <p:sp>
+        <p:nvSpPr>
+          <p:cNvPr id="15" name="Rectangle 14"/>
           <p:cNvSpPr/>
           <p:nvPr/>
         </p:nvSpPr>
         <p:spPr>
           <a:xfrm>
-            <a:off x="3666744" y="1417320"/>
-            <a:ext cx="36576" cy="8229600"/>
+            <a:off x="118872" y="1444751"/>
+            <a:ext cx="4882895" cy="2029968"/>
+          </a:xfrm>
+          <a:prstGeom prst="rect">
+            <a:avLst/>
+          </a:prstGeom>
+          <a:solidFill>
+            <a:srgbClr val="0D1E2E"/>
+          </a:solidFill>
+          <a:ln w="10160">
+            <a:solidFill>
+              <a:srgbClr val="3A6AB0"/>
+            </a:solidFill>
+          </a:ln>
+        </p:spPr>
+        <p:style>
+          <a:lnRef idx="1">
+            <a:schemeClr val="accent1"/>
+          </a:lnRef>
+          <a:fillRef idx="3">
+            <a:schemeClr val="accent1"/>
+          </a:fillRef>
+          <a:effectRef idx="2">
+            <a:schemeClr val="accent1"/>
+          </a:effectRef>
+          <a:fontRef idx="minor">
+            <a:schemeClr val="lt1"/>
+          </a:fontRef>
+        </p:style>
+        <p:txBody>
+          <a:bodyPr rtlCol="0" anchor="ctr"/>
+          <a:lstStyle/>
+          <a:p>
+            <a:pPr algn="ctr"/>
+          </a:p>
+        </p:txBody>
+      </p:sp>
+      <p:sp>
+        <p:nvSpPr>
+          <p:cNvPr id="16" name="TextBox 15"/>
+          <p:cNvSpPr txBox="1"/>
+          <p:nvPr/>
+        </p:nvSpPr>
+        <p:spPr>
+          <a:xfrm>
+            <a:off x="164592" y="1536192"/>
+            <a:ext cx="4791455" cy="182880"/>
+          </a:xfrm>
+          <a:prstGeom prst="rect">
+            <a:avLst/>
+          </a:prstGeom>
+          <a:noFill/>
+        </p:spPr>
+        <p:txBody>
+          <a:bodyPr wrap="square">
+            <a:spAutoFit/>
+          </a:bodyPr>
+          <a:lstStyle/>
+          <a:p>
+            <a:pPr algn="l"/>
+            <a:r>
+              <a:rPr sz="800" b="1" i="0">
+                <a:solidFill>
+                  <a:srgbClr val="FDE499"/>
+                </a:solidFill>
+              </a:rPr>
+              <a:t>PROBLEM STATEMENT</a:t>
+            </a:r>
+          </a:p>
+        </p:txBody>
+      </p:sp>
+      <p:sp>
+        <p:nvSpPr>
+          <p:cNvPr id="17" name="Rectangle 16"/>
+          <p:cNvSpPr/>
+          <p:nvPr/>
+        </p:nvSpPr>
+        <p:spPr>
+          <a:xfrm>
+            <a:off x="164592" y="1719072"/>
+            <a:ext cx="4791455" cy="16459"/>
+          </a:xfrm>
+          <a:prstGeom prst="rect">
+            <a:avLst/>
+          </a:prstGeom>
+          <a:solidFill>
+            <a:srgbClr val="FDE499"/>
+          </a:solidFill>
+          <a:ln>
+            <a:noFill/>
+          </a:ln>
+        </p:spPr>
+        <p:style>
+          <a:lnRef idx="1">
+            <a:schemeClr val="accent1"/>
+          </a:lnRef>
+          <a:fillRef idx="3">
+            <a:schemeClr val="accent1"/>
+          </a:fillRef>
+          <a:effectRef idx="2">
+            <a:schemeClr val="accent1"/>
+          </a:effectRef>
+          <a:fontRef idx="minor">
+            <a:schemeClr val="lt1"/>
+          </a:fontRef>
+        </p:style>
+        <p:txBody>
+          <a:bodyPr rtlCol="0" anchor="ctr"/>
+          <a:lstStyle/>
+          <a:p>
+            <a:pPr algn="ctr"/>
+          </a:p>
+        </p:txBody>
+      </p:sp>
+      <p:sp>
+        <p:nvSpPr>
+          <p:cNvPr id="18" name="TextBox 17"/>
+          <p:cNvSpPr txBox="1"/>
+          <p:nvPr/>
+        </p:nvSpPr>
+        <p:spPr>
+          <a:xfrm>
+            <a:off x="164592" y="1792224"/>
+            <a:ext cx="4791455" cy="1691640"/>
+          </a:xfrm>
+          <a:prstGeom prst="rect">
+            <a:avLst/>
+          </a:prstGeom>
+          <a:noFill/>
+        </p:spPr>
+        <p:txBody>
+          <a:bodyPr wrap="square">
+            <a:spAutoFit/>
+          </a:bodyPr>
+          <a:lstStyle/>
+          <a:p>
+            <a:pPr algn="l"/>
+            <a:r>
+              <a:rPr sz="800" b="0" i="0">
+                <a:solidFill>
+                  <a:srgbClr val="D0DFF5"/>
+                </a:solidFill>
+              </a:rPr>
+              <a:t>India's 63 million small businesses run on WhatsApp groups, shared Excel files, and paper registers.</a:t>
+            </a:r>
+          </a:p>
+          <a:p>
+            <a:pPr algn="l"/>
+            <a:r>
+              <a:rPr sz="400" b="0" i="0">
+                <a:solidFill>
+                  <a:srgbClr val="D0DFF5"/>
+                </a:solidFill>
+              </a:rPr>
+              <a:t/>
+            </a:r>
+          </a:p>
+          <a:p>
+            <a:pPr algn="l"/>
+            <a:r>
+              <a:rPr sz="800" b="0" i="0">
+                <a:solidFill>
+                  <a:srgbClr val="D0DFF5"/>
+                </a:solidFill>
+              </a:rPr>
+              <a:t>Their data is scattered, unsecured, and disconnected. Tools don't talk to each other — a customer exists as separate records in 4 different spreadsheets.</a:t>
+            </a:r>
+          </a:p>
+          <a:p>
+            <a:pPr algn="l"/>
+            <a:r>
+              <a:rPr sz="400" b="0" i="0">
+                <a:solidFill>
+                  <a:srgbClr val="D0DFF5"/>
+                </a:solidFill>
+              </a:rPr>
+              <a:t/>
+            </a:r>
+          </a:p>
+          <a:p>
+            <a:pPr algn="l"/>
+            <a:r>
+              <a:rPr sz="800" b="0" i="0">
+                <a:solidFill>
+                  <a:srgbClr val="D0DFF5"/>
+                </a:solidFill>
+              </a:rPr>
+              <a:t>Enterprise tools like Salesforce cost ₹40,000+/month and take months to set up. There is no affordable, simple, all-in-one solution built for them.</a:t>
+            </a:r>
+          </a:p>
+        </p:txBody>
+      </p:sp>
+      <p:sp>
+        <p:nvSpPr>
+          <p:cNvPr id="19" name="TextBox 18"/>
+          <p:cNvSpPr txBox="1"/>
+          <p:nvPr/>
+        </p:nvSpPr>
+        <p:spPr>
+          <a:xfrm>
+            <a:off x="164592" y="3602736"/>
+            <a:ext cx="4791455" cy="182880"/>
+          </a:xfrm>
+          <a:prstGeom prst="rect">
+            <a:avLst/>
+          </a:prstGeom>
+          <a:noFill/>
+        </p:spPr>
+        <p:txBody>
+          <a:bodyPr wrap="square">
+            <a:spAutoFit/>
+          </a:bodyPr>
+          <a:lstStyle/>
+          <a:p>
+            <a:pPr algn="l"/>
+            <a:r>
+              <a:rPr sz="800" b="1" i="0">
+                <a:solidFill>
+                  <a:srgbClr val="2E5395"/>
+                </a:solidFill>
+              </a:rPr>
+              <a:t>USER EMPATHY MAP</a:t>
+            </a:r>
+          </a:p>
+        </p:txBody>
+      </p:sp>
+      <p:sp>
+        <p:nvSpPr>
+          <p:cNvPr id="20" name="Rectangle 19"/>
+          <p:cNvSpPr/>
+          <p:nvPr/>
+        </p:nvSpPr>
+        <p:spPr>
+          <a:xfrm>
+            <a:off x="164592" y="3785615"/>
+            <a:ext cx="4791455" cy="16459"/>
           </a:xfrm>
           <a:prstGeom prst="rect">
             <a:avLst/>
@@ -3722,23 +3958,25 @@
       </p:sp>
       <p:sp>
         <p:nvSpPr>
-          <p:cNvPr id="19" name="Rectangle 18"/>
+          <p:cNvPr id="21" name="Rectangle 20"/>
           <p:cNvSpPr/>
           <p:nvPr/>
         </p:nvSpPr>
         <p:spPr>
           <a:xfrm>
-            <a:off x="10936224" y="1417320"/>
-            <a:ext cx="36576" cy="8229600"/>
+            <a:off x="164592" y="3858768"/>
+            <a:ext cx="2350008" cy="1389888"/>
           </a:xfrm>
           <a:prstGeom prst="rect">
             <a:avLst/>
           </a:prstGeom>
           <a:solidFill>
-            <a:srgbClr val="1A3A6E"/>
+            <a:srgbClr val="FDE499"/>
           </a:solidFill>
-          <a:ln>
-            <a:noFill/>
+          <a:ln w="6350">
+            <a:solidFill>
+              <a:srgbClr val="FDC430"/>
+            </a:solidFill>
           </a:ln>
         </p:spPr>
         <p:style>
@@ -3765,57 +4003,14 @@
       </p:sp>
       <p:sp>
         <p:nvSpPr>
-          <p:cNvPr id="20" name="Rectangle 19"/>
-          <p:cNvSpPr/>
-          <p:nvPr/>
-        </p:nvSpPr>
-        <p:spPr>
-          <a:xfrm>
-            <a:off x="91439" y="1481328"/>
-            <a:ext cx="3474720" cy="1920240"/>
-          </a:xfrm>
-          <a:prstGeom prst="rect">
-            <a:avLst/>
-          </a:prstGeom>
-          <a:solidFill>
-            <a:srgbClr val="0D1E2E"/>
-          </a:solidFill>
-          <a:ln>
-            <a:noFill/>
-          </a:ln>
-        </p:spPr>
-        <p:style>
-          <a:lnRef idx="1">
-            <a:schemeClr val="accent1"/>
-          </a:lnRef>
-          <a:fillRef idx="3">
-            <a:schemeClr val="accent1"/>
-          </a:fillRef>
-          <a:effectRef idx="2">
-            <a:schemeClr val="accent1"/>
-          </a:effectRef>
-          <a:fontRef idx="minor">
-            <a:schemeClr val="lt1"/>
-          </a:fontRef>
-        </p:style>
-        <p:txBody>
-          <a:bodyPr rtlCol="0" anchor="ctr"/>
-          <a:lstStyle/>
-          <a:p>
-            <a:pPr algn="ctr"/>
-          </a:p>
-        </p:txBody>
-      </p:sp>
-      <p:sp>
-        <p:nvSpPr>
-          <p:cNvPr id="21" name="TextBox 20"/>
+          <p:cNvPr id="22" name="TextBox 21"/>
           <p:cNvSpPr txBox="1"/>
           <p:nvPr/>
         </p:nvSpPr>
         <p:spPr>
           <a:xfrm>
-            <a:off x="137160" y="1554480"/>
-            <a:ext cx="3383280" cy="201168"/>
+            <a:off x="256032" y="3922776"/>
+            <a:ext cx="2212848" cy="201168"/>
           </a:xfrm>
           <a:prstGeom prst="rect">
             <a:avLst/>
@@ -3830,56 +4025,13 @@
           <a:p>
             <a:pPr algn="l"/>
             <a:r>
-              <a:rPr sz="800" b="1" i="0">
-                <a:solidFill>
-                  <a:srgbClr val="FDE499"/>
-                </a:solidFill>
-              </a:rPr>
-              <a:t>PROBLEM STATEMENT</a:t>
-            </a:r>
-          </a:p>
-        </p:txBody>
-      </p:sp>
-      <p:sp>
-        <p:nvSpPr>
-          <p:cNvPr id="22" name="Rectangle 21"/>
-          <p:cNvSpPr/>
-          <p:nvPr/>
-        </p:nvSpPr>
-        <p:spPr>
-          <a:xfrm>
-            <a:off x="137160" y="1755648"/>
-            <a:ext cx="3383280" cy="18288"/>
-          </a:xfrm>
-          <a:prstGeom prst="rect">
-            <a:avLst/>
-          </a:prstGeom>
-          <a:solidFill>
-            <a:srgbClr val="FDE499"/>
-          </a:solidFill>
-          <a:ln>
-            <a:noFill/>
-          </a:ln>
-        </p:spPr>
-        <p:style>
-          <a:lnRef idx="1">
-            <a:schemeClr val="accent1"/>
-          </a:lnRef>
-          <a:fillRef idx="3">
-            <a:schemeClr val="accent1"/>
-          </a:fillRef>
-          <a:effectRef idx="2">
-            <a:schemeClr val="accent1"/>
-          </a:effectRef>
-          <a:fontRef idx="minor">
-            <a:schemeClr val="lt1"/>
-          </a:fontRef>
-        </p:style>
-        <p:txBody>
-          <a:bodyPr rtlCol="0" anchor="ctr"/>
-          <a:lstStyle/>
-          <a:p>
-            <a:pPr algn="ctr"/>
+              <a:rPr sz="750" b="1" i="0">
+                <a:solidFill>
+                  <a:srgbClr val="7A5C00"/>
+                </a:solidFill>
+              </a:rPr>
+              <a:t>💬  SAYS</a:t>
+            </a:r>
           </a:p>
         </p:txBody>
       </p:sp>
@@ -3891,8 +4043,8 @@
         </p:nvSpPr>
         <p:spPr>
           <a:xfrm>
-            <a:off x="137160" y="1828800"/>
-            <a:ext cx="3383280" cy="1554480"/>
+            <a:off x="256032" y="4133087"/>
+            <a:ext cx="2212848" cy="1005840"/>
           </a:xfrm>
           <a:prstGeom prst="rect">
             <a:avLst/>
@@ -3907,20 +4059,20 @@
           <a:p>
             <a:pPr algn="l"/>
             <a:r>
-              <a:rPr sz="750" b="0">
-                <a:solidFill>
-                  <a:srgbClr val="D0DFF5"/>
-                </a:solidFill>
-              </a:rPr>
-              <a:t>India's 63 million small businesses run on WhatsApp groups, shared Excel files, and paper registers.</a:t>
-            </a:r>
-          </a:p>
-          <a:p>
-            <a:pPr algn="l"/>
-            <a:r>
-              <a:rPr sz="750" b="0">
-                <a:solidFill>
-                  <a:srgbClr val="D0DFF5"/>
+              <a:rPr sz="750" b="0" i="0">
+                <a:solidFill>
+                  <a:srgbClr val="1A1A2E"/>
+                </a:solidFill>
+              </a:rPr>
+              <a:t>"Our stock data is on my manager's laptop."</a:t>
+            </a:r>
+          </a:p>
+          <a:p>
+            <a:pPr algn="l"/>
+            <a:r>
+              <a:rPr sz="300" b="0" i="0">
+                <a:solidFill>
+                  <a:srgbClr val="1A1A2E"/>
                 </a:solidFill>
               </a:rPr>
               <a:t/>
@@ -3929,271 +4081,26 @@
           <a:p>
             <a:pPr algn="l"/>
             <a:r>
-              <a:rPr sz="750" b="0">
-                <a:solidFill>
-                  <a:srgbClr val="D0DFF5"/>
-                </a:solidFill>
-              </a:rPr>
-              <a:t>Their data is scattered, unsecured, and disconnected across tools that don't talk to each other.</a:t>
-            </a:r>
-          </a:p>
-          <a:p>
-            <a:pPr algn="l"/>
-            <a:r>
-              <a:rPr sz="750" b="0">
-                <a:solidFill>
-                  <a:srgbClr val="D0DFF5"/>
-                </a:solidFill>
-              </a:rPr>
-              <a:t/>
-            </a:r>
-          </a:p>
-          <a:p>
-            <a:pPr algn="l"/>
-            <a:r>
-              <a:rPr sz="750" b="0">
-                <a:solidFill>
-                  <a:srgbClr val="D0DFF5"/>
-                </a:solidFill>
-              </a:rPr>
-              <a:t>Enterprise tools like Salesforce cost ₹40,000+/month and take months to set up — completely out of reach for small teams.</a:t>
-            </a:r>
-          </a:p>
-          <a:p>
-            <a:pPr algn="l"/>
-            <a:r>
-              <a:rPr sz="750" b="0">
-                <a:solidFill>
-                  <a:srgbClr val="D0DFF5"/>
-                </a:solidFill>
-              </a:rPr>
-              <a:t/>
-            </a:r>
-          </a:p>
-          <a:p>
-            <a:pPr algn="l"/>
-            <a:r>
-              <a:rPr sz="750" b="0">
-                <a:solidFill>
-                  <a:srgbClr val="D0DFF5"/>
-                </a:solidFill>
-              </a:rPr>
-              <a:t>There is no affordable, simple, all-in-one solution built for them.</a:t>
-            </a:r>
-          </a:p>
-        </p:txBody>
-      </p:sp>
-      <p:sp>
-        <p:nvSpPr>
-          <p:cNvPr id="24" name="TextBox 23"/>
-          <p:cNvSpPr txBox="1"/>
-          <p:nvPr/>
-        </p:nvSpPr>
-        <p:spPr>
-          <a:xfrm>
-            <a:off x="137160" y="3520440"/>
-            <a:ext cx="3383280" cy="201168"/>
-          </a:xfrm>
-          <a:prstGeom prst="rect">
-            <a:avLst/>
-          </a:prstGeom>
-          <a:noFill/>
-        </p:spPr>
-        <p:txBody>
-          <a:bodyPr wrap="square">
-            <a:spAutoFit/>
-          </a:bodyPr>
-          <a:lstStyle/>
-          <a:p>
-            <a:pPr algn="l"/>
-            <a:r>
-              <a:rPr sz="800" b="1" i="0">
-                <a:solidFill>
-                  <a:srgbClr val="2E5395"/>
-                </a:solidFill>
-              </a:rPr>
-              <a:t>USER EMPATHY MAP</a:t>
-            </a:r>
-          </a:p>
-        </p:txBody>
-      </p:sp>
-      <p:sp>
-        <p:nvSpPr>
-          <p:cNvPr id="25" name="Rectangle 24"/>
+              <a:rPr sz="750" b="0" i="0">
+                <a:solidFill>
+                  <a:srgbClr val="1A1A2E"/>
+                </a:solidFill>
+              </a:rPr>
+              <a:t>"We track leads on WhatsApp — it's a mess."</a:t>
+            </a:r>
+          </a:p>
+        </p:txBody>
+      </p:sp>
+      <p:sp>
+        <p:nvSpPr>
+          <p:cNvPr id="24" name="Rectangle 23"/>
           <p:cNvSpPr/>
           <p:nvPr/>
         </p:nvSpPr>
         <p:spPr>
           <a:xfrm>
-            <a:off x="137160" y="3721608"/>
-            <a:ext cx="3383280" cy="18288"/>
-          </a:xfrm>
-          <a:prstGeom prst="rect">
-            <a:avLst/>
-          </a:prstGeom>
-          <a:solidFill>
-            <a:srgbClr val="2E5395"/>
-          </a:solidFill>
-          <a:ln>
-            <a:noFill/>
-          </a:ln>
-        </p:spPr>
-        <p:style>
-          <a:lnRef idx="1">
-            <a:schemeClr val="accent1"/>
-          </a:lnRef>
-          <a:fillRef idx="3">
-            <a:schemeClr val="accent1"/>
-          </a:fillRef>
-          <a:effectRef idx="2">
-            <a:schemeClr val="accent1"/>
-          </a:effectRef>
-          <a:fontRef idx="minor">
-            <a:schemeClr val="lt1"/>
-          </a:fontRef>
-        </p:style>
-        <p:txBody>
-          <a:bodyPr rtlCol="0" anchor="ctr"/>
-          <a:lstStyle/>
-          <a:p>
-            <a:pPr algn="ctr"/>
-          </a:p>
-        </p:txBody>
-      </p:sp>
-      <p:sp>
-        <p:nvSpPr>
-          <p:cNvPr id="26" name="Rectangle 25"/>
-          <p:cNvSpPr/>
-          <p:nvPr/>
-        </p:nvSpPr>
-        <p:spPr>
-          <a:xfrm>
-            <a:off x="137160" y="3794760"/>
-            <a:ext cx="1655064" cy="1417320"/>
-          </a:xfrm>
-          <a:prstGeom prst="rect">
-            <a:avLst/>
-          </a:prstGeom>
-          <a:solidFill>
-            <a:srgbClr val="FDE499"/>
-          </a:solidFill>
-          <a:ln w="6350">
-            <a:solidFill>
-              <a:srgbClr val="E6C84A"/>
-            </a:solidFill>
-          </a:ln>
-        </p:spPr>
-        <p:style>
-          <a:lnRef idx="1">
-            <a:schemeClr val="accent1"/>
-          </a:lnRef>
-          <a:fillRef idx="3">
-            <a:schemeClr val="accent1"/>
-          </a:fillRef>
-          <a:effectRef idx="2">
-            <a:schemeClr val="accent1"/>
-          </a:effectRef>
-          <a:fontRef idx="minor">
-            <a:schemeClr val="lt1"/>
-          </a:fontRef>
-        </p:style>
-        <p:txBody>
-          <a:bodyPr rtlCol="0" anchor="ctr"/>
-          <a:lstStyle/>
-          <a:p>
-            <a:pPr algn="ctr"/>
-          </a:p>
-        </p:txBody>
-      </p:sp>
-      <p:sp>
-        <p:nvSpPr>
-          <p:cNvPr id="27" name="TextBox 26"/>
-          <p:cNvSpPr txBox="1"/>
-          <p:nvPr/>
-        </p:nvSpPr>
-        <p:spPr>
-          <a:xfrm>
-            <a:off x="210311" y="3849624"/>
-            <a:ext cx="1563624" cy="201168"/>
-          </a:xfrm>
-          <a:prstGeom prst="rect">
-            <a:avLst/>
-          </a:prstGeom>
-          <a:noFill/>
-        </p:spPr>
-        <p:txBody>
-          <a:bodyPr wrap="square">
-            <a:spAutoFit/>
-          </a:bodyPr>
-          <a:lstStyle/>
-          <a:p>
-            <a:pPr algn="l"/>
-            <a:r>
-              <a:rPr sz="750" b="1" i="0">
-                <a:solidFill>
-                  <a:srgbClr val="7A5C00"/>
-                </a:solidFill>
-              </a:rPr>
-              <a:t>💬 SAYS</a:t>
-            </a:r>
-          </a:p>
-        </p:txBody>
-      </p:sp>
-      <p:sp>
-        <p:nvSpPr>
-          <p:cNvPr id="28" name="TextBox 27"/>
-          <p:cNvSpPr txBox="1"/>
-          <p:nvPr/>
-        </p:nvSpPr>
-        <p:spPr>
-          <a:xfrm>
-            <a:off x="210311" y="4050792"/>
-            <a:ext cx="1563624" cy="1097280"/>
-          </a:xfrm>
-          <a:prstGeom prst="rect">
-            <a:avLst/>
-          </a:prstGeom>
-          <a:noFill/>
-        </p:spPr>
-        <p:txBody>
-          <a:bodyPr wrap="square">
-            <a:spAutoFit/>
-          </a:bodyPr>
-          <a:lstStyle/>
-          <a:p>
-            <a:pPr algn="l"/>
-            <a:r>
-              <a:rPr sz="750" b="0">
-                <a:solidFill>
-                  <a:srgbClr val="1A1A2E"/>
-                </a:solidFill>
-              </a:rPr>
-              <a:t>"Our stock data is on my manager's laptop."</a:t>
-            </a:r>
-          </a:p>
-          <a:p>
-            <a:pPr algn="l"/>
-            <a:r>
-              <a:rPr sz="750" b="0">
-                <a:solidFill>
-                  <a:srgbClr val="1A1A2E"/>
-                </a:solidFill>
-              </a:rPr>
-              <a:t>"We track leads on WhatsApp — it's a mess."</a:t>
-            </a:r>
-          </a:p>
-        </p:txBody>
-      </p:sp>
-      <p:sp>
-        <p:nvSpPr>
-          <p:cNvPr id="29" name="Rectangle 28"/>
-          <p:cNvSpPr/>
-          <p:nvPr/>
-        </p:nvSpPr>
-        <p:spPr>
-          <a:xfrm>
-            <a:off x="1865376" y="3794760"/>
-            <a:ext cx="1655064" cy="1417320"/>
+            <a:off x="2606040" y="3858768"/>
+            <a:ext cx="2350008" cy="1389888"/>
           </a:xfrm>
           <a:prstGeom prst="rect">
             <a:avLst/>
@@ -4229,14 +4136,14 @@
       </p:sp>
       <p:sp>
         <p:nvSpPr>
-          <p:cNvPr id="30" name="TextBox 29"/>
+          <p:cNvPr id="25" name="TextBox 24"/>
           <p:cNvSpPr txBox="1"/>
           <p:nvPr/>
         </p:nvSpPr>
         <p:spPr>
           <a:xfrm>
-            <a:off x="1938528" y="3849624"/>
-            <a:ext cx="1563624" cy="201168"/>
+            <a:off x="2697480" y="3922776"/>
+            <a:ext cx="2212848" cy="201168"/>
           </a:xfrm>
           <a:prstGeom prst="rect">
             <a:avLst/>
@@ -4256,21 +4163,21 @@
                   <a:srgbClr val="6B0040"/>
                 </a:solidFill>
               </a:rPr>
-              <a:t>❤️ FEELS</a:t>
-            </a:r>
-          </a:p>
-        </p:txBody>
-      </p:sp>
-      <p:sp>
-        <p:nvSpPr>
-          <p:cNvPr id="31" name="TextBox 30"/>
+              <a:t>❤️  FEELS</a:t>
+            </a:r>
+          </a:p>
+        </p:txBody>
+      </p:sp>
+      <p:sp>
+        <p:nvSpPr>
+          <p:cNvPr id="26" name="TextBox 25"/>
           <p:cNvSpPr txBox="1"/>
           <p:nvPr/>
         </p:nvSpPr>
         <p:spPr>
           <a:xfrm>
-            <a:off x="1938528" y="4050792"/>
-            <a:ext cx="1563624" cy="1097280"/>
+            <a:off x="2697480" y="4133087"/>
+            <a:ext cx="2212848" cy="1005840"/>
           </a:xfrm>
           <a:prstGeom prst="rect">
             <a:avLst/>
@@ -4285,37 +4192,48 @@
           <a:p>
             <a:pPr algn="l"/>
             <a:r>
-              <a:rPr sz="750" b="0">
+              <a:rPr sz="750" b="0" i="0">
                 <a:solidFill>
                   <a:srgbClr val="1A1A2E"/>
                 </a:solidFill>
               </a:rPr>
-              <a:t>Frustrated by constant data loss.</a:t>
-            </a:r>
-          </a:p>
-          <a:p>
-            <a:pPr algn="l"/>
-            <a:r>
-              <a:rPr sz="750" b="0">
+              <a:t>Frustrated by constant data loss and confusion.</a:t>
+            </a:r>
+          </a:p>
+          <a:p>
+            <a:pPr algn="l"/>
+            <a:r>
+              <a:rPr sz="300" b="0" i="0">
                 <a:solidFill>
                   <a:srgbClr val="1A1A2E"/>
                 </a:solidFill>
               </a:rPr>
-              <a:t>Anxious about scaling with no proper system in place.</a:t>
-            </a:r>
-          </a:p>
-        </p:txBody>
-      </p:sp>
-      <p:sp>
-        <p:nvSpPr>
-          <p:cNvPr id="32" name="Rectangle 31"/>
+              <a:t/>
+            </a:r>
+          </a:p>
+          <a:p>
+            <a:pPr algn="l"/>
+            <a:r>
+              <a:rPr sz="750" b="0" i="0">
+                <a:solidFill>
+                  <a:srgbClr val="1A1A2E"/>
+                </a:solidFill>
+              </a:rPr>
+              <a:t>Anxious about scaling with no proper system.</a:t>
+            </a:r>
+          </a:p>
+        </p:txBody>
+      </p:sp>
+      <p:sp>
+        <p:nvSpPr>
+          <p:cNvPr id="27" name="Rectangle 26"/>
           <p:cNvSpPr/>
           <p:nvPr/>
         </p:nvSpPr>
         <p:spPr>
           <a:xfrm>
-            <a:off x="137160" y="5303520"/>
-            <a:ext cx="1655064" cy="1417320"/>
+            <a:off x="164592" y="5340096"/>
+            <a:ext cx="2350008" cy="1389888"/>
           </a:xfrm>
           <a:prstGeom prst="rect">
             <a:avLst/>
@@ -4351,14 +4269,14 @@
       </p:sp>
       <p:sp>
         <p:nvSpPr>
-          <p:cNvPr id="33" name="TextBox 32"/>
+          <p:cNvPr id="28" name="TextBox 27"/>
           <p:cNvSpPr txBox="1"/>
           <p:nvPr/>
         </p:nvSpPr>
         <p:spPr>
           <a:xfrm>
-            <a:off x="210311" y="5358384"/>
-            <a:ext cx="1563624" cy="201168"/>
+            <a:off x="256032" y="5404104"/>
+            <a:ext cx="2212848" cy="201168"/>
           </a:xfrm>
           <a:prstGeom prst="rect">
             <a:avLst/>
@@ -4378,21 +4296,21 @@
                   <a:srgbClr val="1A4A4E"/>
                 </a:solidFill>
               </a:rPr>
-              <a:t>💭 THINKS</a:t>
-            </a:r>
-          </a:p>
-        </p:txBody>
-      </p:sp>
-      <p:sp>
-        <p:nvSpPr>
-          <p:cNvPr id="34" name="TextBox 33"/>
+              <a:t>💭  THINKS</a:t>
+            </a:r>
+          </a:p>
+        </p:txBody>
+      </p:sp>
+      <p:sp>
+        <p:nvSpPr>
+          <p:cNvPr id="29" name="TextBox 28"/>
           <p:cNvSpPr txBox="1"/>
           <p:nvPr/>
         </p:nvSpPr>
         <p:spPr>
           <a:xfrm>
-            <a:off x="210311" y="5559552"/>
-            <a:ext cx="1563624" cy="1097280"/>
+            <a:off x="256032" y="5614416"/>
+            <a:ext cx="2212848" cy="1005840"/>
           </a:xfrm>
           <a:prstGeom prst="rect">
             <a:avLst/>
@@ -4407,7 +4325,7 @@
           <a:p>
             <a:pPr algn="l"/>
             <a:r>
-              <a:rPr sz="750" b="0">
+              <a:rPr sz="750" b="0" i="0">
                 <a:solidFill>
                   <a:srgbClr val="1A1A2E"/>
                 </a:solidFill>
@@ -4418,11 +4336,22 @@
           <a:p>
             <a:pPr algn="l"/>
             <a:r>
-              <a:rPr sz="750" b="0">
+              <a:rPr sz="300" b="0" i="0">
                 <a:solidFill>
                   <a:srgbClr val="1A1A2E"/>
                 </a:solidFill>
               </a:rPr>
+              <a:t/>
+            </a:r>
+          </a:p>
+          <a:p>
+            <a:pPr algn="l"/>
+            <a:r>
+              <a:rPr sz="750" b="0" i="0">
+                <a:solidFill>
+                  <a:srgbClr val="1A1A2E"/>
+                </a:solidFill>
+              </a:rPr>
               <a:t>"I don't have time to learn complex software."</a:t>
             </a:r>
           </a:p>
@@ -4430,14 +4359,14 @@
       </p:sp>
       <p:sp>
         <p:nvSpPr>
-          <p:cNvPr id="35" name="Rectangle 34"/>
+          <p:cNvPr id="30" name="Rectangle 29"/>
           <p:cNvSpPr/>
           <p:nvPr/>
         </p:nvSpPr>
         <p:spPr>
           <a:xfrm>
-            <a:off x="1865376" y="5303520"/>
-            <a:ext cx="1655064" cy="1417320"/>
+            <a:off x="2606040" y="5340096"/>
+            <a:ext cx="2350008" cy="1389888"/>
           </a:xfrm>
           <a:prstGeom prst="rect">
             <a:avLst/>
@@ -4473,14 +4402,14 @@
       </p:sp>
       <p:sp>
         <p:nvSpPr>
-          <p:cNvPr id="36" name="TextBox 35"/>
+          <p:cNvPr id="31" name="TextBox 30"/>
           <p:cNvSpPr txBox="1"/>
           <p:nvPr/>
         </p:nvSpPr>
         <p:spPr>
           <a:xfrm>
-            <a:off x="1938528" y="5358384"/>
-            <a:ext cx="1563624" cy="201168"/>
+            <a:off x="2697480" y="5404104"/>
+            <a:ext cx="2212848" cy="201168"/>
           </a:xfrm>
           <a:prstGeom prst="rect">
             <a:avLst/>
@@ -4500,21 +4429,21 @@
                   <a:srgbClr val="3D1A7A"/>
                 </a:solidFill>
               </a:rPr>
-              <a:t>🖐 DOES</a:t>
-            </a:r>
-          </a:p>
-        </p:txBody>
-      </p:sp>
-      <p:sp>
-        <p:nvSpPr>
-          <p:cNvPr id="37" name="TextBox 36"/>
+              <a:t>🖐  DOES</a:t>
+            </a:r>
+          </a:p>
+        </p:txBody>
+      </p:sp>
+      <p:sp>
+        <p:nvSpPr>
+          <p:cNvPr id="32" name="TextBox 31"/>
           <p:cNvSpPr txBox="1"/>
           <p:nvPr/>
         </p:nvSpPr>
         <p:spPr>
           <a:xfrm>
-            <a:off x="1938528" y="5559552"/>
-            <a:ext cx="1563624" cy="1097280"/>
+            <a:off x="2697480" y="5614416"/>
+            <a:ext cx="2212848" cy="1005840"/>
           </a:xfrm>
           <a:prstGeom prst="rect">
             <a:avLst/>
@@ -4529,7 +4458,7 @@
           <a:p>
             <a:pPr algn="l"/>
             <a:r>
-              <a:rPr sz="750" b="0">
+              <a:rPr sz="750" b="0" i="0">
                 <a:solidFill>
                   <a:srgbClr val="1A1A2E"/>
                 </a:solidFill>
@@ -4540,11 +4469,22 @@
           <a:p>
             <a:pPr algn="l"/>
             <a:r>
-              <a:rPr sz="750" b="0">
+              <a:rPr sz="300" b="0" i="0">
                 <a:solidFill>
                   <a:srgbClr val="1A1A2E"/>
                 </a:solidFill>
               </a:rPr>
+              <a:t/>
+            </a:r>
+          </a:p>
+          <a:p>
+            <a:pPr algn="l"/>
+            <a:r>
+              <a:rPr sz="750" b="0" i="0">
+                <a:solidFill>
+                  <a:srgbClr val="1A1A2E"/>
+                </a:solidFill>
+              </a:rPr>
               <a:t>Uses WhatsApp for operations and customer support.</a:t>
             </a:r>
           </a:p>
@@ -4552,14 +4492,14 @@
       </p:sp>
       <p:sp>
         <p:nvSpPr>
-          <p:cNvPr id="38" name="Rectangle 37"/>
+          <p:cNvPr id="33" name="Rectangle 32"/>
           <p:cNvSpPr/>
           <p:nvPr/>
         </p:nvSpPr>
         <p:spPr>
           <a:xfrm>
-            <a:off x="91439" y="6830568"/>
-            <a:ext cx="3474720" cy="1417320"/>
+            <a:off x="118872" y="6821424"/>
+            <a:ext cx="4882895" cy="1481328"/>
           </a:xfrm>
           <a:prstGeom prst="rect">
             <a:avLst/>
@@ -4597,14 +4537,14 @@
       </p:sp>
       <p:sp>
         <p:nvSpPr>
-          <p:cNvPr id="39" name="TextBox 38"/>
+          <p:cNvPr id="34" name="TextBox 33"/>
           <p:cNvSpPr txBox="1"/>
           <p:nvPr/>
         </p:nvSpPr>
         <p:spPr>
           <a:xfrm>
-            <a:off x="137160" y="6903720"/>
-            <a:ext cx="3383280" cy="201168"/>
+            <a:off x="164592" y="6912864"/>
+            <a:ext cx="4791455" cy="182880"/>
           </a:xfrm>
           <a:prstGeom prst="rect">
             <a:avLst/>
@@ -4631,14 +4571,14 @@
       </p:sp>
       <p:sp>
         <p:nvSpPr>
-          <p:cNvPr id="40" name="Rectangle 39"/>
+          <p:cNvPr id="35" name="Rectangle 34"/>
           <p:cNvSpPr/>
           <p:nvPr/>
         </p:nvSpPr>
         <p:spPr>
           <a:xfrm>
-            <a:off x="137160" y="7104888"/>
-            <a:ext cx="3383280" cy="18288"/>
+            <a:off x="164592" y="7095744"/>
+            <a:ext cx="4791455" cy="16459"/>
           </a:xfrm>
           <a:prstGeom prst="rect">
             <a:avLst/>
@@ -4674,14 +4614,14 @@
       </p:sp>
       <p:sp>
         <p:nvSpPr>
-          <p:cNvPr id="41" name="TextBox 40"/>
+          <p:cNvPr id="36" name="TextBox 35"/>
           <p:cNvSpPr txBox="1"/>
           <p:nvPr/>
         </p:nvSpPr>
         <p:spPr>
           <a:xfrm>
-            <a:off x="137160" y="7178040"/>
-            <a:ext cx="3383280" cy="1097280"/>
+            <a:off x="164592" y="7168896"/>
+            <a:ext cx="4791455" cy="1143000"/>
           </a:xfrm>
           <a:prstGeom prst="rect">
             <a:avLst/>
@@ -4696,20 +4636,20 @@
           <a:p>
             <a:pPr algn="l"/>
             <a:r>
-              <a:rPr sz="750" b="0">
-                <a:solidFill>
-                  <a:srgbClr val="444444"/>
-                </a:solidFill>
-              </a:rPr>
-              <a:t>Technically feasible using React.js, Node.js + Express, PostgreSQL with tenant-scoped queries, and AWS hosting.</a:t>
-            </a:r>
-          </a:p>
-          <a:p>
-            <a:pPr algn="l"/>
-            <a:r>
-              <a:rPr sz="750" b="0">
-                <a:solidFill>
-                  <a:srgbClr val="444444"/>
+              <a:rPr sz="800" b="0" i="0">
+                <a:solidFill>
+                  <a:srgbClr val="333344"/>
+                </a:solidFill>
+              </a:rPr>
+              <a:t>Technically feasible using proven technologies — React.js frontend, Node.js + Express backend, PostgreSQL with tenant-scoped queries, and AWS for hosting.</a:t>
+            </a:r>
+          </a:p>
+          <a:p>
+            <a:pPr algn="l"/>
+            <a:r>
+              <a:rPr sz="400" b="0" i="0">
+                <a:solidFill>
+                  <a:srgbClr val="1A1A2E"/>
                 </a:solidFill>
               </a:rPr>
               <a:t/>
@@ -4718,9 +4658,9 @@
           <a:p>
             <a:pPr algn="l"/>
             <a:r>
-              <a:rPr sz="750" b="0">
-                <a:solidFill>
-                  <a:srgbClr val="444444"/>
+              <a:rPr sz="800" b="0" i="0">
+                <a:solidFill>
+                  <a:srgbClr val="333344"/>
                 </a:solidFill>
               </a:rPr>
               <a:t>MVP covers 4 modules for Indian SMBs. Architecture supports future expansion: additional modules, third-party marketplace, and white-labeling.</a:t>
@@ -4730,14 +4670,14 @@
       </p:sp>
       <p:sp>
         <p:nvSpPr>
-          <p:cNvPr id="42" name="TextBox 41"/>
+          <p:cNvPr id="37" name="TextBox 36"/>
           <p:cNvSpPr txBox="1"/>
           <p:nvPr/>
         </p:nvSpPr>
         <p:spPr>
           <a:xfrm>
-            <a:off x="3840480" y="1554480"/>
-            <a:ext cx="6949440" cy="201168"/>
+            <a:off x="5330952" y="1536192"/>
+            <a:ext cx="6208776" cy="182880"/>
           </a:xfrm>
           <a:prstGeom prst="rect">
             <a:avLst/>
@@ -4764,14 +4704,14 @@
       </p:sp>
       <p:sp>
         <p:nvSpPr>
-          <p:cNvPr id="43" name="Rectangle 42"/>
+          <p:cNvPr id="38" name="Rectangle 37"/>
           <p:cNvSpPr/>
           <p:nvPr/>
         </p:nvSpPr>
         <p:spPr>
           <a:xfrm>
-            <a:off x="3840480" y="1755648"/>
-            <a:ext cx="6949440" cy="18288"/>
+            <a:off x="5330952" y="1719072"/>
+            <a:ext cx="6208776" cy="16459"/>
           </a:xfrm>
           <a:prstGeom prst="rect">
             <a:avLst/>
@@ -4807,14 +4747,14 @@
       </p:sp>
       <p:sp>
         <p:nvSpPr>
-          <p:cNvPr id="44" name="Oval 43"/>
+          <p:cNvPr id="39" name="Oval 38"/>
           <p:cNvSpPr/>
           <p:nvPr/>
         </p:nvSpPr>
         <p:spPr>
           <a:xfrm>
-            <a:off x="3840480" y="1847088"/>
-            <a:ext cx="256032" cy="256032"/>
+            <a:off x="5330952" y="1810512"/>
+            <a:ext cx="237744" cy="237744"/>
           </a:xfrm>
           <a:prstGeom prst="ellipse">
             <a:avLst/>
@@ -4846,7 +4786,7 @@
           <a:p>
             <a:pPr algn="ctr"/>
             <a:r>
-              <a:rPr sz="750" b="1">
+              <a:rPr sz="700" b="1">
                 <a:solidFill>
                   <a:srgbClr val="1A1A2E"/>
                 </a:solidFill>
@@ -4858,14 +4798,14 @@
       </p:sp>
       <p:sp>
         <p:nvSpPr>
-          <p:cNvPr id="45" name="TextBox 44"/>
+          <p:cNvPr id="40" name="TextBox 39"/>
           <p:cNvSpPr txBox="1"/>
           <p:nvPr/>
         </p:nvSpPr>
         <p:spPr>
           <a:xfrm>
-            <a:off x="4160520" y="1847088"/>
-            <a:ext cx="6629400" cy="182880"/>
+            <a:off x="5632704" y="1792224"/>
+            <a:ext cx="5907024" cy="182880"/>
           </a:xfrm>
           <a:prstGeom prst="rect">
             <a:avLst/>
@@ -4880,7 +4820,7 @@
           <a:p>
             <a:pPr algn="l"/>
             <a:r>
-              <a:rPr sz="850" b="1" i="0">
+              <a:rPr sz="900" b="1" i="0">
                 <a:solidFill>
                   <a:srgbClr val="FFFFFF"/>
                 </a:solidFill>
@@ -4892,14 +4832,14 @@
       </p:sp>
       <p:sp>
         <p:nvSpPr>
-          <p:cNvPr id="46" name="TextBox 45"/>
+          <p:cNvPr id="41" name="TextBox 40"/>
           <p:cNvSpPr txBox="1"/>
           <p:nvPr/>
         </p:nvSpPr>
         <p:spPr>
           <a:xfrm>
-            <a:off x="4160520" y="2029968"/>
-            <a:ext cx="6629400" cy="292608"/>
+            <a:off x="5632704" y="1975104"/>
+            <a:ext cx="5907024" cy="274320"/>
           </a:xfrm>
           <a:prstGeom prst="rect">
             <a:avLst/>
@@ -4926,14 +4866,14 @@
       </p:sp>
       <p:sp>
         <p:nvSpPr>
-          <p:cNvPr id="47" name="Oval 46"/>
+          <p:cNvPr id="42" name="Oval 41"/>
           <p:cNvSpPr/>
           <p:nvPr/>
         </p:nvSpPr>
         <p:spPr>
           <a:xfrm>
-            <a:off x="3840480" y="2377440"/>
-            <a:ext cx="256032" cy="256032"/>
+            <a:off x="5330952" y="2322576"/>
+            <a:ext cx="237744" cy="237744"/>
           </a:xfrm>
           <a:prstGeom prst="ellipse">
             <a:avLst/>
@@ -4965,7 +4905,7 @@
           <a:p>
             <a:pPr algn="ctr"/>
             <a:r>
-              <a:rPr sz="750" b="1">
+              <a:rPr sz="700" b="1">
                 <a:solidFill>
                   <a:srgbClr val="1A1A2E"/>
                 </a:solidFill>
@@ -4977,14 +4917,14 @@
       </p:sp>
       <p:sp>
         <p:nvSpPr>
-          <p:cNvPr id="48" name="TextBox 47"/>
+          <p:cNvPr id="43" name="TextBox 42"/>
           <p:cNvSpPr txBox="1"/>
           <p:nvPr/>
         </p:nvSpPr>
         <p:spPr>
           <a:xfrm>
-            <a:off x="4160520" y="2377440"/>
-            <a:ext cx="6629400" cy="182880"/>
+            <a:off x="5632704" y="2304288"/>
+            <a:ext cx="5907024" cy="182880"/>
           </a:xfrm>
           <a:prstGeom prst="rect">
             <a:avLst/>
@@ -4999,7 +4939,7 @@
           <a:p>
             <a:pPr algn="l"/>
             <a:r>
-              <a:rPr sz="850" b="1" i="0">
+              <a:rPr sz="900" b="1" i="0">
                 <a:solidFill>
                   <a:srgbClr val="FFFFFF"/>
                 </a:solidFill>
@@ -5011,14 +4951,14 @@
       </p:sp>
       <p:sp>
         <p:nvSpPr>
-          <p:cNvPr id="49" name="TextBox 48"/>
+          <p:cNvPr id="44" name="TextBox 43"/>
           <p:cNvSpPr txBox="1"/>
           <p:nvPr/>
         </p:nvSpPr>
         <p:spPr>
           <a:xfrm>
-            <a:off x="4160520" y="2560320"/>
-            <a:ext cx="6629400" cy="292608"/>
+            <a:off x="5632704" y="2487168"/>
+            <a:ext cx="5907024" cy="274320"/>
           </a:xfrm>
           <a:prstGeom prst="rect">
             <a:avLst/>
@@ -5045,14 +4985,14 @@
       </p:sp>
       <p:sp>
         <p:nvSpPr>
-          <p:cNvPr id="50" name="Oval 49"/>
+          <p:cNvPr id="45" name="Oval 44"/>
           <p:cNvSpPr/>
           <p:nvPr/>
         </p:nvSpPr>
         <p:spPr>
           <a:xfrm>
-            <a:off x="3840480" y="2907792"/>
-            <a:ext cx="256032" cy="256032"/>
+            <a:off x="5330952" y="2834640"/>
+            <a:ext cx="237744" cy="237744"/>
           </a:xfrm>
           <a:prstGeom prst="ellipse">
             <a:avLst/>
@@ -5084,7 +5024,7 @@
           <a:p>
             <a:pPr algn="ctr"/>
             <a:r>
-              <a:rPr sz="750" b="1">
+              <a:rPr sz="700" b="1">
                 <a:solidFill>
                   <a:srgbClr val="1A1A2E"/>
                 </a:solidFill>
@@ -5096,14 +5036,14 @@
       </p:sp>
       <p:sp>
         <p:nvSpPr>
-          <p:cNvPr id="51" name="TextBox 50"/>
+          <p:cNvPr id="46" name="TextBox 45"/>
           <p:cNvSpPr txBox="1"/>
           <p:nvPr/>
         </p:nvSpPr>
         <p:spPr>
           <a:xfrm>
-            <a:off x="4160520" y="2907792"/>
-            <a:ext cx="6629400" cy="182880"/>
+            <a:off x="5632704" y="2816352"/>
+            <a:ext cx="5907024" cy="182880"/>
           </a:xfrm>
           <a:prstGeom prst="rect">
             <a:avLst/>
@@ -5118,7 +5058,7 @@
           <a:p>
             <a:pPr algn="l"/>
             <a:r>
-              <a:rPr sz="850" b="1" i="0">
+              <a:rPr sz="900" b="1" i="0">
                 <a:solidFill>
                   <a:srgbClr val="FFFFFF"/>
                 </a:solidFill>
@@ -5130,14 +5070,14 @@
       </p:sp>
       <p:sp>
         <p:nvSpPr>
-          <p:cNvPr id="52" name="TextBox 51"/>
+          <p:cNvPr id="47" name="TextBox 46"/>
           <p:cNvSpPr txBox="1"/>
           <p:nvPr/>
         </p:nvSpPr>
         <p:spPr>
           <a:xfrm>
-            <a:off x="4160520" y="3090672"/>
-            <a:ext cx="6629400" cy="292608"/>
+            <a:off x="5632704" y="2999232"/>
+            <a:ext cx="5907024" cy="274320"/>
           </a:xfrm>
           <a:prstGeom prst="rect">
             <a:avLst/>
@@ -5164,14 +5104,14 @@
       </p:sp>
       <p:sp>
         <p:nvSpPr>
-          <p:cNvPr id="53" name="Oval 52"/>
+          <p:cNvPr id="48" name="Oval 47"/>
           <p:cNvSpPr/>
           <p:nvPr/>
         </p:nvSpPr>
         <p:spPr>
           <a:xfrm>
-            <a:off x="3840480" y="3438144"/>
-            <a:ext cx="256032" cy="256032"/>
+            <a:off x="5330952" y="3346704"/>
+            <a:ext cx="237744" cy="237744"/>
           </a:xfrm>
           <a:prstGeom prst="ellipse">
             <a:avLst/>
@@ -5203,7 +5143,7 @@
           <a:p>
             <a:pPr algn="ctr"/>
             <a:r>
-              <a:rPr sz="750" b="1">
+              <a:rPr sz="700" b="1">
                 <a:solidFill>
                   <a:srgbClr val="1A1A2E"/>
                 </a:solidFill>
@@ -5215,14 +5155,14 @@
       </p:sp>
       <p:sp>
         <p:nvSpPr>
-          <p:cNvPr id="54" name="TextBox 53"/>
+          <p:cNvPr id="49" name="TextBox 48"/>
           <p:cNvSpPr txBox="1"/>
           <p:nvPr/>
         </p:nvSpPr>
         <p:spPr>
           <a:xfrm>
-            <a:off x="4160520" y="3438144"/>
-            <a:ext cx="6629400" cy="182880"/>
+            <a:off x="5632704" y="3328416"/>
+            <a:ext cx="5907024" cy="182880"/>
           </a:xfrm>
           <a:prstGeom prst="rect">
             <a:avLst/>
@@ -5237,7 +5177,7 @@
           <a:p>
             <a:pPr algn="l"/>
             <a:r>
-              <a:rPr sz="850" b="1" i="0">
+              <a:rPr sz="900" b="1" i="0">
                 <a:solidFill>
                   <a:srgbClr val="FFFFFF"/>
                 </a:solidFill>
@@ -5249,14 +5189,14 @@
       </p:sp>
       <p:sp>
         <p:nvSpPr>
-          <p:cNvPr id="55" name="TextBox 54"/>
+          <p:cNvPr id="50" name="TextBox 49"/>
           <p:cNvSpPr txBox="1"/>
           <p:nvPr/>
         </p:nvSpPr>
         <p:spPr>
           <a:xfrm>
-            <a:off x="4160520" y="3621024"/>
-            <a:ext cx="6629400" cy="292608"/>
+            <a:off x="5632704" y="3511296"/>
+            <a:ext cx="5907024" cy="274320"/>
           </a:xfrm>
           <a:prstGeom prst="rect">
             <a:avLst/>
@@ -5283,14 +5223,14 @@
       </p:sp>
       <p:sp>
         <p:nvSpPr>
-          <p:cNvPr id="56" name="Oval 55"/>
+          <p:cNvPr id="51" name="Oval 50"/>
           <p:cNvSpPr/>
           <p:nvPr/>
         </p:nvSpPr>
         <p:spPr>
           <a:xfrm>
-            <a:off x="3840480" y="3968496"/>
-            <a:ext cx="256032" cy="256032"/>
+            <a:off x="5330952" y="3858768"/>
+            <a:ext cx="237744" cy="237744"/>
           </a:xfrm>
           <a:prstGeom prst="ellipse">
             <a:avLst/>
@@ -5322,7 +5262,7 @@
           <a:p>
             <a:pPr algn="ctr"/>
             <a:r>
-              <a:rPr sz="750" b="1">
+              <a:rPr sz="700" b="1">
                 <a:solidFill>
                   <a:srgbClr val="1A1A2E"/>
                 </a:solidFill>
@@ -5334,14 +5274,14 @@
       </p:sp>
       <p:sp>
         <p:nvSpPr>
-          <p:cNvPr id="57" name="TextBox 56"/>
+          <p:cNvPr id="52" name="TextBox 51"/>
           <p:cNvSpPr txBox="1"/>
           <p:nvPr/>
         </p:nvSpPr>
         <p:spPr>
           <a:xfrm>
-            <a:off x="4160520" y="3968496"/>
-            <a:ext cx="6629400" cy="182880"/>
+            <a:off x="5632704" y="3840480"/>
+            <a:ext cx="5907024" cy="182880"/>
           </a:xfrm>
           <a:prstGeom prst="rect">
             <a:avLst/>
@@ -5356,7 +5296,7 @@
           <a:p>
             <a:pPr algn="l"/>
             <a:r>
-              <a:rPr sz="850" b="1" i="0">
+              <a:rPr sz="900" b="1" i="0">
                 <a:solidFill>
                   <a:srgbClr val="FFFFFF"/>
                 </a:solidFill>
@@ -5368,14 +5308,14 @@
       </p:sp>
       <p:sp>
         <p:nvSpPr>
-          <p:cNvPr id="58" name="TextBox 57"/>
+          <p:cNvPr id="53" name="TextBox 52"/>
           <p:cNvSpPr txBox="1"/>
           <p:nvPr/>
         </p:nvSpPr>
         <p:spPr>
           <a:xfrm>
-            <a:off x="4160520" y="4151376"/>
-            <a:ext cx="6629400" cy="292608"/>
+            <a:off x="5632704" y="4023360"/>
+            <a:ext cx="5907024" cy="274320"/>
           </a:xfrm>
           <a:prstGeom prst="rect">
             <a:avLst/>
@@ -5402,14 +5342,14 @@
       </p:sp>
       <p:sp>
         <p:nvSpPr>
-          <p:cNvPr id="59" name="Rectangle 58"/>
+          <p:cNvPr id="54" name="Rectangle 53"/>
           <p:cNvSpPr/>
           <p:nvPr/>
         </p:nvSpPr>
         <p:spPr>
           <a:xfrm>
-            <a:off x="3840480" y="4590288"/>
-            <a:ext cx="6949440" cy="18288"/>
+            <a:off x="5330952" y="4398264"/>
+            <a:ext cx="6208776" cy="16459"/>
           </a:xfrm>
           <a:prstGeom prst="rect">
             <a:avLst/>
@@ -5445,14 +5385,14 @@
       </p:sp>
       <p:sp>
         <p:nvSpPr>
-          <p:cNvPr id="60" name="TextBox 59"/>
+          <p:cNvPr id="55" name="TextBox 54"/>
           <p:cNvSpPr txBox="1"/>
           <p:nvPr/>
         </p:nvSpPr>
         <p:spPr>
           <a:xfrm>
-            <a:off x="3840480" y="4700016"/>
-            <a:ext cx="6949440" cy="201168"/>
+            <a:off x="5330952" y="4517136"/>
+            <a:ext cx="6208776" cy="182880"/>
           </a:xfrm>
           <a:prstGeom prst="rect">
             <a:avLst/>
@@ -5479,14 +5419,14 @@
       </p:sp>
       <p:sp>
         <p:nvSpPr>
-          <p:cNvPr id="61" name="Rectangle 60"/>
+          <p:cNvPr id="56" name="Rectangle 55"/>
           <p:cNvSpPr/>
           <p:nvPr/>
         </p:nvSpPr>
         <p:spPr>
           <a:xfrm>
-            <a:off x="3840480" y="4901183"/>
-            <a:ext cx="6949440" cy="18288"/>
+            <a:off x="5330952" y="4700016"/>
+            <a:ext cx="6208776" cy="16459"/>
           </a:xfrm>
           <a:prstGeom prst="rect">
             <a:avLst/>
@@ -5522,24 +5462,24 @@
       </p:sp>
       <p:sp>
         <p:nvSpPr>
-          <p:cNvPr id="62" name="Rectangle 61"/>
+          <p:cNvPr id="57" name="Rectangle 56"/>
           <p:cNvSpPr/>
           <p:nvPr/>
         </p:nvSpPr>
         <p:spPr>
           <a:xfrm>
-            <a:off x="3840480" y="4992624"/>
-            <a:ext cx="3429000" cy="594360"/>
+            <a:off x="5330952" y="4773168"/>
+            <a:ext cx="3049524" cy="603504"/>
           </a:xfrm>
           <a:prstGeom prst="rect">
             <a:avLst/>
           </a:prstGeom>
           <a:solidFill>
-            <a:srgbClr val="EEF2FA"/>
+            <a:srgbClr val="1E415F"/>
           </a:solidFill>
-          <a:ln w="6350">
+          <a:ln w="3810">
             <a:solidFill>
-              <a:srgbClr val="C5D3EA"/>
+              <a:srgbClr val="1A3A6E"/>
             </a:solidFill>
           </a:ln>
         </p:spPr>
@@ -5567,20 +5507,20 @@
       </p:sp>
       <p:sp>
         <p:nvSpPr>
-          <p:cNvPr id="63" name="Rectangle 62"/>
+          <p:cNvPr id="58" name="Rectangle 57"/>
           <p:cNvSpPr/>
           <p:nvPr/>
         </p:nvSpPr>
         <p:spPr>
           <a:xfrm>
-            <a:off x="3840480" y="4992624"/>
-            <a:ext cx="36576" cy="594360"/>
+            <a:off x="5330952" y="4773168"/>
+            <a:ext cx="36576" cy="603504"/>
           </a:xfrm>
           <a:prstGeom prst="rect">
             <a:avLst/>
           </a:prstGeom>
           <a:solidFill>
-            <a:srgbClr val="2E5395"/>
+            <a:srgbClr val="FDE499"/>
           </a:solidFill>
           <a:ln>
             <a:noFill/>
@@ -5610,14 +5550,14 @@
       </p:sp>
       <p:sp>
         <p:nvSpPr>
-          <p:cNvPr id="64" name="TextBox 63"/>
+          <p:cNvPr id="59" name="TextBox 58"/>
           <p:cNvSpPr txBox="1"/>
           <p:nvPr/>
         </p:nvSpPr>
         <p:spPr>
           <a:xfrm>
-            <a:off x="3931920" y="5047488"/>
-            <a:ext cx="3291840" cy="201168"/>
+            <a:off x="5422392" y="4837176"/>
+            <a:ext cx="2921508" cy="201168"/>
           </a:xfrm>
           <a:prstGeom prst="rect">
             <a:avLst/>
@@ -5632,26 +5572,26 @@
           <a:p>
             <a:pPr algn="l"/>
             <a:r>
-              <a:rPr sz="850" b="1" i="0">
-                <a:solidFill>
-                  <a:srgbClr val="2E5395"/>
-                </a:solidFill>
-              </a:rPr>
-              <a:t>📊 CRM</a:t>
-            </a:r>
-          </a:p>
-        </p:txBody>
-      </p:sp>
-      <p:sp>
-        <p:nvSpPr>
-          <p:cNvPr id="65" name="TextBox 64"/>
+              <a:rPr sz="900" b="1" i="0">
+                <a:solidFill>
+                  <a:srgbClr val="FDE499"/>
+                </a:solidFill>
+              </a:rPr>
+              <a:t>📊  CRM</a:t>
+            </a:r>
+          </a:p>
+        </p:txBody>
+      </p:sp>
+      <p:sp>
+        <p:nvSpPr>
+          <p:cNvPr id="60" name="TextBox 59"/>
           <p:cNvSpPr txBox="1"/>
           <p:nvPr/>
         </p:nvSpPr>
         <p:spPr>
           <a:xfrm>
-            <a:off x="3931920" y="5248656"/>
-            <a:ext cx="3291840" cy="292608"/>
+            <a:off x="5422392" y="5047488"/>
+            <a:ext cx="2921508" cy="292608"/>
           </a:xfrm>
           <a:prstGeom prst="rect">
             <a:avLst/>
@@ -5668,7 +5608,7 @@
             <a:r>
               <a:rPr sz="700" b="0" i="0">
                 <a:solidFill>
-                  <a:srgbClr val="444444"/>
+                  <a:srgbClr val="D0DFF5"/>
                 </a:solidFill>
               </a:rPr>
               <a:t>Leads, contacts, deals &amp; sales pipeline for sales teams</a:t>
@@ -5678,24 +5618,24 @@
       </p:sp>
       <p:sp>
         <p:nvSpPr>
-          <p:cNvPr id="66" name="Rectangle 65"/>
+          <p:cNvPr id="61" name="Rectangle 60"/>
           <p:cNvSpPr/>
           <p:nvPr/>
         </p:nvSpPr>
         <p:spPr>
           <a:xfrm>
-            <a:off x="7360920" y="4992624"/>
-            <a:ext cx="3429000" cy="594360"/>
+            <a:off x="8490204" y="4773168"/>
+            <a:ext cx="3049524" cy="603504"/>
           </a:xfrm>
           <a:prstGeom prst="rect">
             <a:avLst/>
           </a:prstGeom>
           <a:solidFill>
-            <a:srgbClr val="EEF2FA"/>
+            <a:srgbClr val="F9FAD9"/>
           </a:solidFill>
-          <a:ln w="6350">
+          <a:ln w="3810">
             <a:solidFill>
-              <a:srgbClr val="C5D3EA"/>
+              <a:srgbClr val="1A3A6E"/>
             </a:solidFill>
           </a:ln>
         </p:spPr>
@@ -5723,20 +5663,20 @@
       </p:sp>
       <p:sp>
         <p:nvSpPr>
-          <p:cNvPr id="67" name="Rectangle 66"/>
+          <p:cNvPr id="62" name="Rectangle 61"/>
           <p:cNvSpPr/>
           <p:nvPr/>
         </p:nvSpPr>
         <p:spPr>
           <a:xfrm>
-            <a:off x="7360920" y="4992624"/>
-            <a:ext cx="36576" cy="594360"/>
+            <a:off x="8490204" y="4773168"/>
+            <a:ext cx="36576" cy="603504"/>
           </a:xfrm>
           <a:prstGeom prst="rect">
             <a:avLst/>
           </a:prstGeom>
           <a:solidFill>
-            <a:srgbClr val="2E5395"/>
+            <a:srgbClr val="FDE499"/>
           </a:solidFill>
           <a:ln>
             <a:noFill/>
@@ -5766,14 +5706,14 @@
       </p:sp>
       <p:sp>
         <p:nvSpPr>
-          <p:cNvPr id="68" name="TextBox 67"/>
+          <p:cNvPr id="63" name="TextBox 62"/>
           <p:cNvSpPr txBox="1"/>
           <p:nvPr/>
         </p:nvSpPr>
         <p:spPr>
           <a:xfrm>
-            <a:off x="7452360" y="5047488"/>
-            <a:ext cx="3291840" cy="201168"/>
+            <a:off x="8581644" y="4837176"/>
+            <a:ext cx="2921508" cy="201168"/>
           </a:xfrm>
           <a:prstGeom prst="rect">
             <a:avLst/>
@@ -5788,26 +5728,26 @@
           <a:p>
             <a:pPr algn="l"/>
             <a:r>
-              <a:rPr sz="850" b="1" i="0">
+              <a:rPr sz="900" b="1" i="0">
                 <a:solidFill>
                   <a:srgbClr val="2E5395"/>
                 </a:solidFill>
               </a:rPr>
-              <a:t>📦 Inventory</a:t>
-            </a:r>
-          </a:p>
-        </p:txBody>
-      </p:sp>
-      <p:sp>
-        <p:nvSpPr>
-          <p:cNvPr id="69" name="TextBox 68"/>
+              <a:t>📦  Inventory</a:t>
+            </a:r>
+          </a:p>
+        </p:txBody>
+      </p:sp>
+      <p:sp>
+        <p:nvSpPr>
+          <p:cNvPr id="64" name="TextBox 63"/>
           <p:cNvSpPr txBox="1"/>
           <p:nvPr/>
         </p:nvSpPr>
         <p:spPr>
           <a:xfrm>
-            <a:off x="7452360" y="5248656"/>
-            <a:ext cx="3291840" cy="292608"/>
+            <a:off x="8581644" y="5047488"/>
+            <a:ext cx="2921508" cy="292608"/>
           </a:xfrm>
           <a:prstGeom prst="rect">
             <a:avLst/>
@@ -5824,7 +5764,7 @@
             <a:r>
               <a:rPr sz="700" b="0" i="0">
                 <a:solidFill>
-                  <a:srgbClr val="444444"/>
+                  <a:srgbClr val="333344"/>
                 </a:solidFill>
               </a:rPr>
               <a:t>Products, stock levels, orders &amp; supplier management</a:t>
@@ -5834,24 +5774,24 @@
       </p:sp>
       <p:sp>
         <p:nvSpPr>
-          <p:cNvPr id="70" name="Rectangle 69"/>
+          <p:cNvPr id="65" name="Rectangle 64"/>
           <p:cNvSpPr/>
           <p:nvPr/>
         </p:nvSpPr>
         <p:spPr>
           <a:xfrm>
-            <a:off x="3840480" y="5650992"/>
-            <a:ext cx="3429000" cy="594360"/>
+            <a:off x="5330952" y="5431536"/>
+            <a:ext cx="3049524" cy="603504"/>
           </a:xfrm>
           <a:prstGeom prst="rect">
             <a:avLst/>
           </a:prstGeom>
           <a:solidFill>
-            <a:srgbClr val="EEF2FA"/>
+            <a:srgbClr val="F9FAD9"/>
           </a:solidFill>
-          <a:ln w="6350">
+          <a:ln w="3810">
             <a:solidFill>
-              <a:srgbClr val="C5D3EA"/>
+              <a:srgbClr val="1A3A6E"/>
             </a:solidFill>
           </a:ln>
         </p:spPr>
@@ -5879,20 +5819,20 @@
       </p:sp>
       <p:sp>
         <p:nvSpPr>
-          <p:cNvPr id="71" name="Rectangle 70"/>
+          <p:cNvPr id="66" name="Rectangle 65"/>
           <p:cNvSpPr/>
           <p:nvPr/>
         </p:nvSpPr>
         <p:spPr>
           <a:xfrm>
-            <a:off x="3840480" y="5650992"/>
-            <a:ext cx="36576" cy="594360"/>
+            <a:off x="5330952" y="5431536"/>
+            <a:ext cx="36576" cy="603504"/>
           </a:xfrm>
           <a:prstGeom prst="rect">
             <a:avLst/>
           </a:prstGeom>
           <a:solidFill>
-            <a:srgbClr val="2E5395"/>
+            <a:srgbClr val="FDE499"/>
           </a:solidFill>
           <a:ln>
             <a:noFill/>
@@ -5922,14 +5862,14 @@
       </p:sp>
       <p:sp>
         <p:nvSpPr>
-          <p:cNvPr id="72" name="TextBox 71"/>
+          <p:cNvPr id="67" name="TextBox 66"/>
           <p:cNvSpPr txBox="1"/>
           <p:nvPr/>
         </p:nvSpPr>
         <p:spPr>
           <a:xfrm>
-            <a:off x="3931920" y="5705855"/>
-            <a:ext cx="3291840" cy="201168"/>
+            <a:off x="5422392" y="5495544"/>
+            <a:ext cx="2921508" cy="201168"/>
           </a:xfrm>
           <a:prstGeom prst="rect">
             <a:avLst/>
@@ -5944,26 +5884,26 @@
           <a:p>
             <a:pPr algn="l"/>
             <a:r>
-              <a:rPr sz="850" b="1" i="0">
+              <a:rPr sz="900" b="1" i="0">
                 <a:solidFill>
                   <a:srgbClr val="2E5395"/>
                 </a:solidFill>
               </a:rPr>
-              <a:t>👥 HRMS</a:t>
-            </a:r>
-          </a:p>
-        </p:txBody>
-      </p:sp>
-      <p:sp>
-        <p:nvSpPr>
-          <p:cNvPr id="73" name="TextBox 72"/>
+              <a:t>👥  HRMS</a:t>
+            </a:r>
+          </a:p>
+        </p:txBody>
+      </p:sp>
+      <p:sp>
+        <p:nvSpPr>
+          <p:cNvPr id="68" name="TextBox 67"/>
           <p:cNvSpPr txBox="1"/>
           <p:nvPr/>
         </p:nvSpPr>
         <p:spPr>
           <a:xfrm>
-            <a:off x="3931920" y="5907024"/>
-            <a:ext cx="3291840" cy="292608"/>
+            <a:off x="5422392" y="5705855"/>
+            <a:ext cx="2921508" cy="292608"/>
           </a:xfrm>
           <a:prstGeom prst="rect">
             <a:avLst/>
@@ -5980,7 +5920,7 @@
             <a:r>
               <a:rPr sz="700" b="0" i="0">
                 <a:solidFill>
-                  <a:srgbClr val="444444"/>
+                  <a:srgbClr val="333344"/>
                 </a:solidFill>
               </a:rPr>
               <a:t>Employees, attendance, leave management &amp; payroll</a:t>
@@ -5990,24 +5930,24 @@
       </p:sp>
       <p:sp>
         <p:nvSpPr>
-          <p:cNvPr id="74" name="Rectangle 73"/>
+          <p:cNvPr id="69" name="Rectangle 68"/>
           <p:cNvSpPr/>
           <p:nvPr/>
         </p:nvSpPr>
         <p:spPr>
           <a:xfrm>
-            <a:off x="7360920" y="5650992"/>
-            <a:ext cx="3429000" cy="594360"/>
+            <a:off x="8490204" y="5431536"/>
+            <a:ext cx="3049524" cy="603504"/>
           </a:xfrm>
           <a:prstGeom prst="rect">
             <a:avLst/>
           </a:prstGeom>
           <a:solidFill>
-            <a:srgbClr val="EEF2FA"/>
+            <a:srgbClr val="1E415F"/>
           </a:solidFill>
-          <a:ln w="6350">
+          <a:ln w="3810">
             <a:solidFill>
-              <a:srgbClr val="C5D3EA"/>
+              <a:srgbClr val="1A3A6E"/>
             </a:solidFill>
           </a:ln>
         </p:spPr>
@@ -6035,20 +5975,20 @@
       </p:sp>
       <p:sp>
         <p:nvSpPr>
-          <p:cNvPr id="75" name="Rectangle 74"/>
+          <p:cNvPr id="70" name="Rectangle 69"/>
           <p:cNvSpPr/>
           <p:nvPr/>
         </p:nvSpPr>
         <p:spPr>
           <a:xfrm>
-            <a:off x="7360920" y="5650992"/>
-            <a:ext cx="36576" cy="594360"/>
+            <a:off x="8490204" y="5431536"/>
+            <a:ext cx="36576" cy="603504"/>
           </a:xfrm>
           <a:prstGeom prst="rect">
             <a:avLst/>
           </a:prstGeom>
           <a:solidFill>
-            <a:srgbClr val="2E5395"/>
+            <a:srgbClr val="FDE499"/>
           </a:solidFill>
           <a:ln>
             <a:noFill/>
@@ -6078,14 +6018,14 @@
       </p:sp>
       <p:sp>
         <p:nvSpPr>
-          <p:cNvPr id="76" name="TextBox 75"/>
+          <p:cNvPr id="71" name="TextBox 70"/>
           <p:cNvSpPr txBox="1"/>
           <p:nvPr/>
         </p:nvSpPr>
         <p:spPr>
           <a:xfrm>
-            <a:off x="7452360" y="5705855"/>
-            <a:ext cx="3291840" cy="201168"/>
+            <a:off x="8581644" y="5495544"/>
+            <a:ext cx="2921508" cy="201168"/>
           </a:xfrm>
           <a:prstGeom prst="rect">
             <a:avLst/>
@@ -6100,26 +6040,26 @@
           <a:p>
             <a:pPr algn="l"/>
             <a:r>
-              <a:rPr sz="850" b="1" i="0">
-                <a:solidFill>
-                  <a:srgbClr val="2E5395"/>
-                </a:solidFill>
-              </a:rPr>
-              <a:t>🎫 HelpDesk</a:t>
-            </a:r>
-          </a:p>
-        </p:txBody>
-      </p:sp>
-      <p:sp>
-        <p:nvSpPr>
-          <p:cNvPr id="77" name="TextBox 76"/>
+              <a:rPr sz="900" b="1" i="0">
+                <a:solidFill>
+                  <a:srgbClr val="FDE499"/>
+                </a:solidFill>
+              </a:rPr>
+              <a:t>🎫  HelpDesk</a:t>
+            </a:r>
+          </a:p>
+        </p:txBody>
+      </p:sp>
+      <p:sp>
+        <p:nvSpPr>
+          <p:cNvPr id="72" name="TextBox 71"/>
           <p:cNvSpPr txBox="1"/>
           <p:nvPr/>
         </p:nvSpPr>
         <p:spPr>
           <a:xfrm>
-            <a:off x="7452360" y="5907024"/>
-            <a:ext cx="3291840" cy="292608"/>
+            <a:off x="8581644" y="5705855"/>
+            <a:ext cx="2921508" cy="292608"/>
           </a:xfrm>
           <a:prstGeom prst="rect">
             <a:avLst/>
@@ -6136,7 +6076,7 @@
             <a:r>
               <a:rPr sz="700" b="0" i="0">
                 <a:solidFill>
-                  <a:srgbClr val="444444"/>
+                  <a:srgbClr val="D0DFF5"/>
                 </a:solidFill>
               </a:rPr>
               <a:t>Support tickets, agent assignment &amp; resolution tracking</a:t>
@@ -6146,14 +6086,14 @@
       </p:sp>
       <p:sp>
         <p:nvSpPr>
-          <p:cNvPr id="78" name="Rectangle 77"/>
+          <p:cNvPr id="73" name="Rectangle 72"/>
           <p:cNvSpPr/>
           <p:nvPr/>
         </p:nvSpPr>
         <p:spPr>
           <a:xfrm>
-            <a:off x="3840480" y="6409944"/>
-            <a:ext cx="6949440" cy="18288"/>
+            <a:off x="5330952" y="6208776"/>
+            <a:ext cx="6208776" cy="16459"/>
           </a:xfrm>
           <a:prstGeom prst="rect">
             <a:avLst/>
@@ -6189,14 +6129,14 @@
       </p:sp>
       <p:sp>
         <p:nvSpPr>
-          <p:cNvPr id="79" name="TextBox 78"/>
+          <p:cNvPr id="74" name="TextBox 73"/>
           <p:cNvSpPr txBox="1"/>
           <p:nvPr/>
         </p:nvSpPr>
         <p:spPr>
           <a:xfrm>
-            <a:off x="3840480" y="6519672"/>
-            <a:ext cx="6949440" cy="201168"/>
+            <a:off x="5330952" y="6327648"/>
+            <a:ext cx="6208776" cy="182880"/>
           </a:xfrm>
           <a:prstGeom prst="rect">
             <a:avLst/>
@@ -6223,14 +6163,14 @@
       </p:sp>
       <p:sp>
         <p:nvSpPr>
-          <p:cNvPr id="80" name="Rectangle 79"/>
+          <p:cNvPr id="75" name="Rectangle 74"/>
           <p:cNvSpPr/>
           <p:nvPr/>
         </p:nvSpPr>
         <p:spPr>
           <a:xfrm>
-            <a:off x="3840480" y="6720840"/>
-            <a:ext cx="6949440" cy="18288"/>
+            <a:off x="5330952" y="6510528"/>
+            <a:ext cx="6208776" cy="16459"/>
           </a:xfrm>
           <a:prstGeom prst="rect">
             <a:avLst/>
@@ -6266,14 +6206,14 @@
       </p:sp>
       <p:sp>
         <p:nvSpPr>
-          <p:cNvPr id="81" name="Rectangle 80"/>
+          <p:cNvPr id="76" name="Rectangle 75"/>
           <p:cNvSpPr/>
           <p:nvPr/>
         </p:nvSpPr>
         <p:spPr>
           <a:xfrm>
-            <a:off x="3840480" y="6812280"/>
-            <a:ext cx="822960" cy="219456"/>
+            <a:off x="5330952" y="6583680"/>
+            <a:ext cx="868680" cy="228600"/>
           </a:xfrm>
           <a:prstGeom prst="rect">
             <a:avLst/>
@@ -6317,14 +6257,14 @@
       </p:sp>
       <p:sp>
         <p:nvSpPr>
-          <p:cNvPr id="82" name="TextBox 81"/>
+          <p:cNvPr id="77" name="TextBox 76"/>
           <p:cNvSpPr txBox="1"/>
           <p:nvPr/>
         </p:nvSpPr>
         <p:spPr>
           <a:xfrm>
-            <a:off x="4736592" y="6830568"/>
-            <a:ext cx="6035040" cy="201168"/>
+            <a:off x="6263640" y="6601968"/>
+            <a:ext cx="5257800" cy="201168"/>
           </a:xfrm>
           <a:prstGeom prst="rect">
             <a:avLst/>
@@ -6351,14 +6291,14 @@
       </p:sp>
       <p:sp>
         <p:nvSpPr>
-          <p:cNvPr id="83" name="Rectangle 82"/>
+          <p:cNvPr id="78" name="Rectangle 77"/>
           <p:cNvSpPr/>
           <p:nvPr/>
         </p:nvSpPr>
         <p:spPr>
           <a:xfrm>
-            <a:off x="3840480" y="7104888"/>
-            <a:ext cx="822960" cy="219456"/>
+            <a:off x="5330952" y="6876288"/>
+            <a:ext cx="868680" cy="228600"/>
           </a:xfrm>
           <a:prstGeom prst="rect">
             <a:avLst/>
@@ -6402,14 +6342,14 @@
       </p:sp>
       <p:sp>
         <p:nvSpPr>
-          <p:cNvPr id="84" name="TextBox 83"/>
+          <p:cNvPr id="79" name="TextBox 78"/>
           <p:cNvSpPr txBox="1"/>
           <p:nvPr/>
         </p:nvSpPr>
         <p:spPr>
           <a:xfrm>
-            <a:off x="4736592" y="7123176"/>
-            <a:ext cx="6035040" cy="201168"/>
+            <a:off x="6263640" y="6894576"/>
+            <a:ext cx="5257800" cy="201168"/>
           </a:xfrm>
           <a:prstGeom prst="rect">
             <a:avLst/>
@@ -6436,14 +6376,14 @@
       </p:sp>
       <p:sp>
         <p:nvSpPr>
-          <p:cNvPr id="85" name="Rectangle 84"/>
+          <p:cNvPr id="80" name="Rectangle 79"/>
           <p:cNvSpPr/>
           <p:nvPr/>
         </p:nvSpPr>
         <p:spPr>
           <a:xfrm>
-            <a:off x="3840480" y="7397496"/>
-            <a:ext cx="822960" cy="219456"/>
+            <a:off x="5330952" y="7168896"/>
+            <a:ext cx="868680" cy="228600"/>
           </a:xfrm>
           <a:prstGeom prst="rect">
             <a:avLst/>
@@ -6487,14 +6427,14 @@
       </p:sp>
       <p:sp>
         <p:nvSpPr>
-          <p:cNvPr id="86" name="TextBox 85"/>
+          <p:cNvPr id="81" name="TextBox 80"/>
           <p:cNvSpPr txBox="1"/>
           <p:nvPr/>
         </p:nvSpPr>
         <p:spPr>
           <a:xfrm>
-            <a:off x="4736592" y="7415783"/>
-            <a:ext cx="6035040" cy="201168"/>
+            <a:off x="6263640" y="7187184"/>
+            <a:ext cx="5257800" cy="201168"/>
           </a:xfrm>
           <a:prstGeom prst="rect">
             <a:avLst/>
@@ -6521,14 +6461,14 @@
       </p:sp>
       <p:sp>
         <p:nvSpPr>
-          <p:cNvPr id="87" name="Rectangle 86"/>
+          <p:cNvPr id="82" name="Rectangle 81"/>
           <p:cNvSpPr/>
           <p:nvPr/>
         </p:nvSpPr>
         <p:spPr>
           <a:xfrm>
-            <a:off x="3840480" y="7690104"/>
-            <a:ext cx="822960" cy="219456"/>
+            <a:off x="5330952" y="7461504"/>
+            <a:ext cx="868680" cy="228600"/>
           </a:xfrm>
           <a:prstGeom prst="rect">
             <a:avLst/>
@@ -6572,14 +6512,14 @@
       </p:sp>
       <p:sp>
         <p:nvSpPr>
-          <p:cNvPr id="88" name="TextBox 87"/>
+          <p:cNvPr id="83" name="TextBox 82"/>
           <p:cNvSpPr txBox="1"/>
           <p:nvPr/>
         </p:nvSpPr>
         <p:spPr>
           <a:xfrm>
-            <a:off x="4736592" y="7708392"/>
-            <a:ext cx="6035040" cy="201168"/>
+            <a:off x="6263640" y="7479792"/>
+            <a:ext cx="5257800" cy="201168"/>
           </a:xfrm>
           <a:prstGeom prst="rect">
             <a:avLst/>
@@ -6606,14 +6546,14 @@
       </p:sp>
       <p:sp>
         <p:nvSpPr>
-          <p:cNvPr id="89" name="TextBox 88"/>
+          <p:cNvPr id="84" name="TextBox 83"/>
           <p:cNvSpPr txBox="1"/>
           <p:nvPr/>
         </p:nvSpPr>
         <p:spPr>
           <a:xfrm>
-            <a:off x="11109960" y="1554480"/>
-            <a:ext cx="7040880" cy="201168"/>
+            <a:off x="11914632" y="1536192"/>
+            <a:ext cx="6208776" cy="182880"/>
           </a:xfrm>
           <a:prstGeom prst="rect">
             <a:avLst/>
@@ -6640,14 +6580,14 @@
       </p:sp>
       <p:sp>
         <p:nvSpPr>
-          <p:cNvPr id="90" name="Rectangle 89"/>
+          <p:cNvPr id="85" name="Rectangle 84"/>
           <p:cNvSpPr/>
           <p:nvPr/>
         </p:nvSpPr>
         <p:spPr>
           <a:xfrm>
-            <a:off x="11109960" y="1755648"/>
-            <a:ext cx="7040880" cy="18288"/>
+            <a:off x="11914632" y="1719072"/>
+            <a:ext cx="6208776" cy="16459"/>
           </a:xfrm>
           <a:prstGeom prst="rect">
             <a:avLst/>
@@ -6683,14 +6623,14 @@
       </p:sp>
       <p:sp>
         <p:nvSpPr>
-          <p:cNvPr id="91" name="Oval 90"/>
+          <p:cNvPr id="86" name="Oval 85"/>
           <p:cNvSpPr/>
           <p:nvPr/>
         </p:nvSpPr>
         <p:spPr>
           <a:xfrm>
-            <a:off x="11109960" y="1847088"/>
-            <a:ext cx="256032" cy="256032"/>
+            <a:off x="11914632" y="1810512"/>
+            <a:ext cx="237744" cy="237744"/>
           </a:xfrm>
           <a:prstGeom prst="ellipse">
             <a:avLst/>
@@ -6722,7 +6662,7 @@
           <a:p>
             <a:pPr algn="ctr"/>
             <a:r>
-              <a:rPr sz="650" b="1">
+              <a:rPr sz="700" b="1">
                 <a:solidFill>
                   <a:srgbClr val="1A1A2E"/>
                 </a:solidFill>
@@ -6734,14 +6674,14 @@
       </p:sp>
       <p:sp>
         <p:nvSpPr>
-          <p:cNvPr id="92" name="TextBox 91"/>
+          <p:cNvPr id="87" name="TextBox 86"/>
           <p:cNvSpPr txBox="1"/>
           <p:nvPr/>
         </p:nvSpPr>
         <p:spPr>
           <a:xfrm>
-            <a:off x="11430000" y="1847088"/>
-            <a:ext cx="6720840" cy="182880"/>
+            <a:off x="12216384" y="1792224"/>
+            <a:ext cx="5907024" cy="182880"/>
           </a:xfrm>
           <a:prstGeom prst="rect">
             <a:avLst/>
@@ -6756,7 +6696,7 @@
           <a:p>
             <a:pPr algn="l"/>
             <a:r>
-              <a:rPr sz="850" b="1" i="0">
+              <a:rPr sz="900" b="1" i="0">
                 <a:solidFill>
                   <a:srgbClr val="FFFFFF"/>
                 </a:solidFill>
@@ -6768,14 +6708,14 @@
       </p:sp>
       <p:sp>
         <p:nvSpPr>
-          <p:cNvPr id="93" name="TextBox 92"/>
+          <p:cNvPr id="88" name="TextBox 87"/>
           <p:cNvSpPr txBox="1"/>
           <p:nvPr/>
         </p:nvSpPr>
         <p:spPr>
           <a:xfrm>
-            <a:off x="11430000" y="2029968"/>
-            <a:ext cx="6720840" cy="292608"/>
+            <a:off x="12216384" y="1975104"/>
+            <a:ext cx="5907024" cy="274320"/>
           </a:xfrm>
           <a:prstGeom prst="rect">
             <a:avLst/>
@@ -6802,14 +6742,14 @@
       </p:sp>
       <p:sp>
         <p:nvSpPr>
-          <p:cNvPr id="94" name="Oval 93"/>
+          <p:cNvPr id="89" name="Oval 88"/>
           <p:cNvSpPr/>
           <p:nvPr/>
         </p:nvSpPr>
         <p:spPr>
           <a:xfrm>
-            <a:off x="11109960" y="2377440"/>
-            <a:ext cx="256032" cy="256032"/>
+            <a:off x="11914632" y="2322576"/>
+            <a:ext cx="237744" cy="237744"/>
           </a:xfrm>
           <a:prstGeom prst="ellipse">
             <a:avLst/>
@@ -6841,7 +6781,7 @@
           <a:p>
             <a:pPr algn="ctr"/>
             <a:r>
-              <a:rPr sz="650" b="1">
+              <a:rPr sz="700" b="1">
                 <a:solidFill>
                   <a:srgbClr val="1A1A2E"/>
                 </a:solidFill>
@@ -6853,14 +6793,14 @@
       </p:sp>
       <p:sp>
         <p:nvSpPr>
-          <p:cNvPr id="95" name="TextBox 94"/>
+          <p:cNvPr id="90" name="TextBox 89"/>
           <p:cNvSpPr txBox="1"/>
           <p:nvPr/>
         </p:nvSpPr>
         <p:spPr>
           <a:xfrm>
-            <a:off x="11430000" y="2377440"/>
-            <a:ext cx="6720840" cy="182880"/>
+            <a:off x="12216384" y="2304288"/>
+            <a:ext cx="5907024" cy="182880"/>
           </a:xfrm>
           <a:prstGeom prst="rect">
             <a:avLst/>
@@ -6875,7 +6815,7 @@
           <a:p>
             <a:pPr algn="l"/>
             <a:r>
-              <a:rPr sz="850" b="1" i="0">
+              <a:rPr sz="900" b="1" i="0">
                 <a:solidFill>
                   <a:srgbClr val="FFFFFF"/>
                 </a:solidFill>
@@ -6887,14 +6827,14 @@
       </p:sp>
       <p:sp>
         <p:nvSpPr>
-          <p:cNvPr id="96" name="TextBox 95"/>
+          <p:cNvPr id="91" name="TextBox 90"/>
           <p:cNvSpPr txBox="1"/>
           <p:nvPr/>
         </p:nvSpPr>
         <p:spPr>
           <a:xfrm>
-            <a:off x="11430000" y="2560320"/>
-            <a:ext cx="6720840" cy="292608"/>
+            <a:off x="12216384" y="2487168"/>
+            <a:ext cx="5907024" cy="274320"/>
           </a:xfrm>
           <a:prstGeom prst="rect">
             <a:avLst/>
@@ -6921,14 +6861,14 @@
       </p:sp>
       <p:sp>
         <p:nvSpPr>
-          <p:cNvPr id="97" name="Oval 96"/>
+          <p:cNvPr id="92" name="Oval 91"/>
           <p:cNvSpPr/>
           <p:nvPr/>
         </p:nvSpPr>
         <p:spPr>
           <a:xfrm>
-            <a:off x="11109960" y="2907792"/>
-            <a:ext cx="256032" cy="256032"/>
+            <a:off x="11914632" y="2834640"/>
+            <a:ext cx="237744" cy="237744"/>
           </a:xfrm>
           <a:prstGeom prst="ellipse">
             <a:avLst/>
@@ -6960,7 +6900,7 @@
           <a:p>
             <a:pPr algn="ctr"/>
             <a:r>
-              <a:rPr sz="650" b="1">
+              <a:rPr sz="700" b="1">
                 <a:solidFill>
                   <a:srgbClr val="1A1A2E"/>
                 </a:solidFill>
@@ -6972,14 +6912,14 @@
       </p:sp>
       <p:sp>
         <p:nvSpPr>
-          <p:cNvPr id="98" name="TextBox 97"/>
+          <p:cNvPr id="93" name="TextBox 92"/>
           <p:cNvSpPr txBox="1"/>
           <p:nvPr/>
         </p:nvSpPr>
         <p:spPr>
           <a:xfrm>
-            <a:off x="11430000" y="2907792"/>
-            <a:ext cx="6720840" cy="182880"/>
+            <a:off x="12216384" y="2816352"/>
+            <a:ext cx="5907024" cy="182880"/>
           </a:xfrm>
           <a:prstGeom prst="rect">
             <a:avLst/>
@@ -6994,7 +6934,7 @@
           <a:p>
             <a:pPr algn="l"/>
             <a:r>
-              <a:rPr sz="850" b="1" i="0">
+              <a:rPr sz="900" b="1" i="0">
                 <a:solidFill>
                   <a:srgbClr val="FFFFFF"/>
                 </a:solidFill>
@@ -7006,14 +6946,14 @@
       </p:sp>
       <p:sp>
         <p:nvSpPr>
-          <p:cNvPr id="99" name="TextBox 98"/>
+          <p:cNvPr id="94" name="TextBox 93"/>
           <p:cNvSpPr txBox="1"/>
           <p:nvPr/>
         </p:nvSpPr>
         <p:spPr>
           <a:xfrm>
-            <a:off x="11430000" y="3090672"/>
-            <a:ext cx="6720840" cy="292608"/>
+            <a:off x="12216384" y="2999232"/>
+            <a:ext cx="5907024" cy="274320"/>
           </a:xfrm>
           <a:prstGeom prst="rect">
             <a:avLst/>
@@ -7040,14 +6980,14 @@
       </p:sp>
       <p:sp>
         <p:nvSpPr>
-          <p:cNvPr id="100" name="Oval 99"/>
+          <p:cNvPr id="95" name="Oval 94"/>
           <p:cNvSpPr/>
           <p:nvPr/>
         </p:nvSpPr>
         <p:spPr>
           <a:xfrm>
-            <a:off x="11109960" y="3438144"/>
-            <a:ext cx="256032" cy="256032"/>
+            <a:off x="11914632" y="3346704"/>
+            <a:ext cx="237744" cy="237744"/>
           </a:xfrm>
           <a:prstGeom prst="ellipse">
             <a:avLst/>
@@ -7079,7 +7019,7 @@
           <a:p>
             <a:pPr algn="ctr"/>
             <a:r>
-              <a:rPr sz="650" b="1">
+              <a:rPr sz="700" b="1">
                 <a:solidFill>
                   <a:srgbClr val="1A1A2E"/>
                 </a:solidFill>
@@ -7091,14 +7031,14 @@
       </p:sp>
       <p:sp>
         <p:nvSpPr>
-          <p:cNvPr id="101" name="TextBox 100"/>
+          <p:cNvPr id="96" name="TextBox 95"/>
           <p:cNvSpPr txBox="1"/>
           <p:nvPr/>
         </p:nvSpPr>
         <p:spPr>
           <a:xfrm>
-            <a:off x="11430000" y="3438144"/>
-            <a:ext cx="6720840" cy="182880"/>
+            <a:off x="12216384" y="3328416"/>
+            <a:ext cx="5907024" cy="182880"/>
           </a:xfrm>
           <a:prstGeom prst="rect">
             <a:avLst/>
@@ -7113,7 +7053,7 @@
           <a:p>
             <a:pPr algn="l"/>
             <a:r>
-              <a:rPr sz="850" b="1" i="0">
+              <a:rPr sz="900" b="1" i="0">
                 <a:solidFill>
                   <a:srgbClr val="FFFFFF"/>
                 </a:solidFill>
@@ -7125,14 +7065,14 @@
       </p:sp>
       <p:sp>
         <p:nvSpPr>
-          <p:cNvPr id="102" name="TextBox 101"/>
+          <p:cNvPr id="97" name="TextBox 96"/>
           <p:cNvSpPr txBox="1"/>
           <p:nvPr/>
         </p:nvSpPr>
         <p:spPr>
           <a:xfrm>
-            <a:off x="11430000" y="3621024"/>
-            <a:ext cx="6720840" cy="292608"/>
+            <a:off x="12216384" y="3511296"/>
+            <a:ext cx="5907024" cy="274320"/>
           </a:xfrm>
           <a:prstGeom prst="rect">
             <a:avLst/>
@@ -7159,14 +7099,14 @@
       </p:sp>
       <p:sp>
         <p:nvSpPr>
-          <p:cNvPr id="103" name="Oval 102"/>
+          <p:cNvPr id="98" name="Oval 97"/>
           <p:cNvSpPr/>
           <p:nvPr/>
         </p:nvSpPr>
         <p:spPr>
           <a:xfrm>
-            <a:off x="11109960" y="3968496"/>
-            <a:ext cx="256032" cy="256032"/>
+            <a:off x="11914632" y="3858768"/>
+            <a:ext cx="237744" cy="237744"/>
           </a:xfrm>
           <a:prstGeom prst="ellipse">
             <a:avLst/>
@@ -7198,7 +7138,7 @@
           <a:p>
             <a:pPr algn="ctr"/>
             <a:r>
-              <a:rPr sz="650" b="1">
+              <a:rPr sz="700" b="1">
                 <a:solidFill>
                   <a:srgbClr val="1A1A2E"/>
                 </a:solidFill>
@@ -7210,14 +7150,14 @@
       </p:sp>
       <p:sp>
         <p:nvSpPr>
-          <p:cNvPr id="104" name="TextBox 103"/>
+          <p:cNvPr id="99" name="TextBox 98"/>
           <p:cNvSpPr txBox="1"/>
           <p:nvPr/>
         </p:nvSpPr>
         <p:spPr>
           <a:xfrm>
-            <a:off x="11430000" y="3968496"/>
-            <a:ext cx="6720840" cy="182880"/>
+            <a:off x="12216384" y="3840480"/>
+            <a:ext cx="5907024" cy="182880"/>
           </a:xfrm>
           <a:prstGeom prst="rect">
             <a:avLst/>
@@ -7232,7 +7172,7 @@
           <a:p>
             <a:pPr algn="l"/>
             <a:r>
-              <a:rPr sz="850" b="1" i="0">
+              <a:rPr sz="900" b="1" i="0">
                 <a:solidFill>
                   <a:srgbClr val="FFFFFF"/>
                 </a:solidFill>
@@ -7244,14 +7184,14 @@
       </p:sp>
       <p:sp>
         <p:nvSpPr>
-          <p:cNvPr id="105" name="TextBox 104"/>
+          <p:cNvPr id="100" name="TextBox 99"/>
           <p:cNvSpPr txBox="1"/>
           <p:nvPr/>
         </p:nvSpPr>
         <p:spPr>
           <a:xfrm>
-            <a:off x="11430000" y="4151376"/>
-            <a:ext cx="6720840" cy="292608"/>
+            <a:off x="12216384" y="4023360"/>
+            <a:ext cx="5907024" cy="274320"/>
           </a:xfrm>
           <a:prstGeom prst="rect">
             <a:avLst/>
@@ -7278,14 +7218,14 @@
       </p:sp>
       <p:sp>
         <p:nvSpPr>
-          <p:cNvPr id="106" name="Rectangle 105"/>
+          <p:cNvPr id="101" name="Rectangle 100"/>
           <p:cNvSpPr/>
           <p:nvPr/>
         </p:nvSpPr>
         <p:spPr>
           <a:xfrm>
-            <a:off x="11109960" y="4590288"/>
-            <a:ext cx="7040880" cy="18288"/>
+            <a:off x="11914632" y="4398264"/>
+            <a:ext cx="6208776" cy="16459"/>
           </a:xfrm>
           <a:prstGeom prst="rect">
             <a:avLst/>
@@ -7321,14 +7261,14 @@
       </p:sp>
       <p:sp>
         <p:nvSpPr>
-          <p:cNvPr id="107" name="TextBox 106"/>
+          <p:cNvPr id="102" name="TextBox 101"/>
           <p:cNvSpPr txBox="1"/>
           <p:nvPr/>
         </p:nvSpPr>
         <p:spPr>
           <a:xfrm>
-            <a:off x="11109960" y="4700016"/>
-            <a:ext cx="7040880" cy="201168"/>
+            <a:off x="11914632" y="4517136"/>
+            <a:ext cx="6208776" cy="182880"/>
           </a:xfrm>
           <a:prstGeom prst="rect">
             <a:avLst/>
@@ -7355,14 +7295,14 @@
       </p:sp>
       <p:sp>
         <p:nvSpPr>
-          <p:cNvPr id="108" name="Rectangle 107"/>
+          <p:cNvPr id="103" name="Rectangle 102"/>
           <p:cNvSpPr/>
           <p:nvPr/>
         </p:nvSpPr>
         <p:spPr>
           <a:xfrm>
-            <a:off x="11109960" y="4901183"/>
-            <a:ext cx="7040880" cy="18288"/>
+            <a:off x="11914632" y="4700016"/>
+            <a:ext cx="6208776" cy="16459"/>
           </a:xfrm>
           <a:prstGeom prst="rect">
             <a:avLst/>
@@ -7398,13 +7338,13 @@
       </p:sp>
       <p:sp>
         <p:nvSpPr>
-          <p:cNvPr id="109" name="Oval 108"/>
+          <p:cNvPr id="104" name="Oval 103"/>
           <p:cNvSpPr/>
           <p:nvPr/>
         </p:nvSpPr>
         <p:spPr>
           <a:xfrm>
-            <a:off x="11109960" y="5020056"/>
+            <a:off x="11914632" y="4809744"/>
             <a:ext cx="182880" cy="182880"/>
           </a:xfrm>
           <a:prstGeom prst="ellipse">
@@ -7437,7 +7377,7 @@
           <a:p>
             <a:pPr algn="ctr"/>
             <a:r>
-              <a:rPr sz="600">
+              <a:rPr sz="700" b="1">
                 <a:solidFill>
                   <a:srgbClr val="1A1A2E"/>
                 </a:solidFill>
@@ -7449,14 +7389,14 @@
       </p:sp>
       <p:sp>
         <p:nvSpPr>
-          <p:cNvPr id="110" name="TextBox 109"/>
+          <p:cNvPr id="105" name="TextBox 104"/>
           <p:cNvSpPr txBox="1"/>
           <p:nvPr/>
         </p:nvSpPr>
         <p:spPr>
           <a:xfrm>
-            <a:off x="11365992" y="4992624"/>
-            <a:ext cx="6784848" cy="164592"/>
+            <a:off x="12170663" y="4773168"/>
+            <a:ext cx="5952744" cy="182880"/>
           </a:xfrm>
           <a:prstGeom prst="rect">
             <a:avLst/>
@@ -7471,7 +7411,7 @@
           <a:p>
             <a:pPr algn="l"/>
             <a:r>
-              <a:rPr sz="850" b="1" i="0">
+              <a:rPr sz="900" b="1" i="0">
                 <a:solidFill>
                   <a:srgbClr val="FFFFFF"/>
                 </a:solidFill>
@@ -7483,14 +7423,14 @@
       </p:sp>
       <p:sp>
         <p:nvSpPr>
-          <p:cNvPr id="111" name="TextBox 110"/>
+          <p:cNvPr id="106" name="TextBox 105"/>
           <p:cNvSpPr txBox="1"/>
           <p:nvPr/>
         </p:nvSpPr>
         <p:spPr>
           <a:xfrm>
-            <a:off x="11365992" y="5157216"/>
-            <a:ext cx="6784848" cy="256032"/>
+            <a:off x="12170663" y="4956048"/>
+            <a:ext cx="5952744" cy="274320"/>
           </a:xfrm>
           <a:prstGeom prst="rect">
             <a:avLst/>
@@ -7510,20 +7450,20 @@
                   <a:srgbClr val="D0DFF5"/>
                 </a:solidFill>
               </a:rPr>
-              <a:t>Businesses assemble their own toolset by activating modules — like Shopify apps.</a:t>
-            </a:r>
-          </a:p>
-        </p:txBody>
-      </p:sp>
-      <p:sp>
-        <p:nvSpPr>
-          <p:cNvPr id="112" name="Oval 111"/>
+              <a:t>Businesses assemble their own toolset by activating modules — like Shopify apps for their business OS.</a:t>
+            </a:r>
+          </a:p>
+        </p:txBody>
+      </p:sp>
+      <p:sp>
+        <p:nvSpPr>
+          <p:cNvPr id="107" name="Oval 106"/>
           <p:cNvSpPr/>
           <p:nvPr/>
         </p:nvSpPr>
         <p:spPr>
           <a:xfrm>
-            <a:off x="11109960" y="5477256"/>
+            <a:off x="11914632" y="5303520"/>
             <a:ext cx="182880" cy="182880"/>
           </a:xfrm>
           <a:prstGeom prst="ellipse">
@@ -7556,7 +7496,7 @@
           <a:p>
             <a:pPr algn="ctr"/>
             <a:r>
-              <a:rPr sz="600">
+              <a:rPr sz="700" b="1">
                 <a:solidFill>
                   <a:srgbClr val="1A1A2E"/>
                 </a:solidFill>
@@ -7568,14 +7508,14 @@
       </p:sp>
       <p:sp>
         <p:nvSpPr>
-          <p:cNvPr id="113" name="TextBox 112"/>
+          <p:cNvPr id="108" name="TextBox 107"/>
           <p:cNvSpPr txBox="1"/>
           <p:nvPr/>
         </p:nvSpPr>
         <p:spPr>
           <a:xfrm>
-            <a:off x="11365992" y="5449824"/>
-            <a:ext cx="6784848" cy="164592"/>
+            <a:off x="12170663" y="5266944"/>
+            <a:ext cx="5952744" cy="182880"/>
           </a:xfrm>
           <a:prstGeom prst="rect">
             <a:avLst/>
@@ -7590,7 +7530,7 @@
           <a:p>
             <a:pPr algn="l"/>
             <a:r>
-              <a:rPr sz="850" b="1" i="0">
+              <a:rPr sz="900" b="1" i="0">
                 <a:solidFill>
                   <a:srgbClr val="FFFFFF"/>
                 </a:solidFill>
@@ -7602,14 +7542,14 @@
       </p:sp>
       <p:sp>
         <p:nvSpPr>
-          <p:cNvPr id="114" name="TextBox 113"/>
+          <p:cNvPr id="109" name="TextBox 108"/>
           <p:cNvSpPr txBox="1"/>
           <p:nvPr/>
         </p:nvSpPr>
         <p:spPr>
           <a:xfrm>
-            <a:off x="11365992" y="5614416"/>
-            <a:ext cx="6784848" cy="256032"/>
+            <a:off x="12170663" y="5449824"/>
+            <a:ext cx="5952744" cy="274320"/>
           </a:xfrm>
           <a:prstGeom prst="rect">
             <a:avLst/>
@@ -7629,20 +7569,20 @@
                   <a:srgbClr val="D0DFF5"/>
                 </a:solidFill>
               </a:rPr>
-              <a:t>Every query is scoped with tenant_id at the database level, not just the UI.</a:t>
-            </a:r>
-          </a:p>
-        </p:txBody>
-      </p:sp>
-      <p:sp>
-        <p:nvSpPr>
-          <p:cNvPr id="115" name="Oval 114"/>
+              <a:t>Every query is scoped with tenant_id at the database level, not just the UI layer.</a:t>
+            </a:r>
+          </a:p>
+        </p:txBody>
+      </p:sp>
+      <p:sp>
+        <p:nvSpPr>
+          <p:cNvPr id="110" name="Oval 109"/>
           <p:cNvSpPr/>
           <p:nvPr/>
         </p:nvSpPr>
         <p:spPr>
           <a:xfrm>
-            <a:off x="11109960" y="5934456"/>
+            <a:off x="11914632" y="5797296"/>
             <a:ext cx="182880" cy="182880"/>
           </a:xfrm>
           <a:prstGeom prst="ellipse">
@@ -7675,7 +7615,7 @@
           <a:p>
             <a:pPr algn="ctr"/>
             <a:r>
-              <a:rPr sz="600">
+              <a:rPr sz="700" b="1">
                 <a:solidFill>
                   <a:srgbClr val="1A1A2E"/>
                 </a:solidFill>
@@ -7687,14 +7627,14 @@
       </p:sp>
       <p:sp>
         <p:nvSpPr>
-          <p:cNvPr id="116" name="TextBox 115"/>
+          <p:cNvPr id="111" name="TextBox 110"/>
           <p:cNvSpPr txBox="1"/>
           <p:nvPr/>
         </p:nvSpPr>
         <p:spPr>
           <a:xfrm>
-            <a:off x="11365992" y="5907024"/>
-            <a:ext cx="6784848" cy="164592"/>
+            <a:off x="12170663" y="5760720"/>
+            <a:ext cx="5952744" cy="182880"/>
           </a:xfrm>
           <a:prstGeom prst="rect">
             <a:avLst/>
@@ -7709,7 +7649,7 @@
           <a:p>
             <a:pPr algn="l"/>
             <a:r>
-              <a:rPr sz="850" b="1" i="0">
+              <a:rPr sz="900" b="1" i="0">
                 <a:solidFill>
                   <a:srgbClr val="FFFFFF"/>
                 </a:solidFill>
@@ -7721,14 +7661,14 @@
       </p:sp>
       <p:sp>
         <p:nvSpPr>
-          <p:cNvPr id="117" name="TextBox 116"/>
+          <p:cNvPr id="112" name="TextBox 111"/>
           <p:cNvSpPr txBox="1"/>
           <p:nvPr/>
         </p:nvSpPr>
         <p:spPr>
           <a:xfrm>
-            <a:off x="11365992" y="6071616"/>
-            <a:ext cx="6784848" cy="256032"/>
+            <a:off x="12170663" y="5943600"/>
+            <a:ext cx="5952744" cy="274320"/>
           </a:xfrm>
           <a:prstGeom prst="rect">
             <a:avLst/>
@@ -7748,20 +7688,20 @@
                   <a:srgbClr val="D0DFF5"/>
                 </a:solidFill>
               </a:rPr>
-              <a:t>Auth → Tenant → RBAC → Module checks on every single API request.</a:t>
-            </a:r>
-          </a:p>
-        </p:txBody>
-      </p:sp>
-      <p:sp>
-        <p:nvSpPr>
-          <p:cNvPr id="118" name="Oval 117"/>
+              <a:t>Auth → Tenant → RBAC → Module checks on every single API request, no exceptions.</a:t>
+            </a:r>
+          </a:p>
+        </p:txBody>
+      </p:sp>
+      <p:sp>
+        <p:nvSpPr>
+          <p:cNvPr id="113" name="Oval 112"/>
           <p:cNvSpPr/>
           <p:nvPr/>
         </p:nvSpPr>
         <p:spPr>
           <a:xfrm>
-            <a:off x="11109960" y="6391656"/>
+            <a:off x="11914632" y="6291072"/>
             <a:ext cx="182880" cy="182880"/>
           </a:xfrm>
           <a:prstGeom prst="ellipse">
@@ -7794,7 +7734,7 @@
           <a:p>
             <a:pPr algn="ctr"/>
             <a:r>
-              <a:rPr sz="600">
+              <a:rPr sz="700" b="1">
                 <a:solidFill>
                   <a:srgbClr val="1A1A2E"/>
                 </a:solidFill>
@@ -7806,14 +7746,14 @@
       </p:sp>
       <p:sp>
         <p:nvSpPr>
-          <p:cNvPr id="119" name="TextBox 118"/>
+          <p:cNvPr id="114" name="TextBox 113"/>
           <p:cNvSpPr txBox="1"/>
           <p:nvPr/>
         </p:nvSpPr>
         <p:spPr>
           <a:xfrm>
-            <a:off x="11365992" y="6364224"/>
-            <a:ext cx="6784848" cy="164592"/>
+            <a:off x="12170663" y="6254496"/>
+            <a:ext cx="5952744" cy="182880"/>
           </a:xfrm>
           <a:prstGeom prst="rect">
             <a:avLst/>
@@ -7828,7 +7768,7 @@
           <a:p>
             <a:pPr algn="l"/>
             <a:r>
-              <a:rPr sz="850" b="1" i="0">
+              <a:rPr sz="900" b="1" i="0">
                 <a:solidFill>
                   <a:srgbClr val="FFFFFF"/>
                 </a:solidFill>
@@ -7840,14 +7780,14 @@
       </p:sp>
       <p:sp>
         <p:nvSpPr>
-          <p:cNvPr id="120" name="TextBox 119"/>
+          <p:cNvPr id="115" name="TextBox 114"/>
           <p:cNvSpPr txBox="1"/>
           <p:nvPr/>
         </p:nvSpPr>
         <p:spPr>
           <a:xfrm>
-            <a:off x="11365992" y="6528816"/>
-            <a:ext cx="6784848" cy="256032"/>
+            <a:off x="12170663" y="6437376"/>
+            <a:ext cx="5952744" cy="274320"/>
           </a:xfrm>
           <a:prstGeom prst="rect">
             <a:avLst/>
@@ -7867,21 +7807,21 @@
                   <a:srgbClr val="D0DFF5"/>
                 </a:solidFill>
               </a:rPr>
-              <a:t>Free for small teams, affordable paid plans. No ₹40,000/month Salesforce trap.</a:t>
-            </a:r>
-          </a:p>
-        </p:txBody>
-      </p:sp>
-      <p:sp>
-        <p:nvSpPr>
-          <p:cNvPr id="121" name="Rectangle 120"/>
+              <a:t>Free for small teams, affordable paid plans. No ₹40,000/month Salesforce trap for SMBs.</a:t>
+            </a:r>
+          </a:p>
+        </p:txBody>
+      </p:sp>
+      <p:sp>
+        <p:nvSpPr>
+          <p:cNvPr id="116" name="Rectangle 115"/>
           <p:cNvSpPr/>
           <p:nvPr/>
         </p:nvSpPr>
         <p:spPr>
           <a:xfrm>
-            <a:off x="11109960" y="6867144"/>
-            <a:ext cx="7040880" cy="18288"/>
+            <a:off x="11914632" y="6793992"/>
+            <a:ext cx="6208776" cy="16459"/>
           </a:xfrm>
           <a:prstGeom prst="rect">
             <a:avLst/>
@@ -7917,14 +7857,14 @@
       </p:sp>
       <p:sp>
         <p:nvSpPr>
-          <p:cNvPr id="122" name="TextBox 121"/>
+          <p:cNvPr id="117" name="TextBox 116"/>
           <p:cNvSpPr txBox="1"/>
           <p:nvPr/>
         </p:nvSpPr>
         <p:spPr>
           <a:xfrm>
-            <a:off x="11109960" y="6976872"/>
-            <a:ext cx="7040880" cy="201168"/>
+            <a:off x="11914632" y="6912864"/>
+            <a:ext cx="6208776" cy="182880"/>
           </a:xfrm>
           <a:prstGeom prst="rect">
             <a:avLst/>
@@ -7951,14 +7891,14 @@
       </p:sp>
       <p:sp>
         <p:nvSpPr>
-          <p:cNvPr id="123" name="Rectangle 122"/>
+          <p:cNvPr id="118" name="Rectangle 117"/>
           <p:cNvSpPr/>
           <p:nvPr/>
         </p:nvSpPr>
         <p:spPr>
           <a:xfrm>
-            <a:off x="11109960" y="7178040"/>
-            <a:ext cx="7040880" cy="18288"/>
+            <a:off x="11914632" y="7095744"/>
+            <a:ext cx="6208776" cy="16459"/>
           </a:xfrm>
           <a:prstGeom prst="rect">
             <a:avLst/>
@@ -7994,14 +7934,14 @@
       </p:sp>
       <p:sp>
         <p:nvSpPr>
-          <p:cNvPr id="124" name="Rectangle 123"/>
+          <p:cNvPr id="119" name="Rectangle 118"/>
           <p:cNvSpPr/>
           <p:nvPr/>
         </p:nvSpPr>
         <p:spPr>
           <a:xfrm>
-            <a:off x="11109960" y="7269480"/>
-            <a:ext cx="3474720" cy="402336"/>
+            <a:off x="11914632" y="7168896"/>
+            <a:ext cx="3049524" cy="420624"/>
           </a:xfrm>
           <a:prstGeom prst="rect">
             <a:avLst/>
@@ -8009,8 +7949,10 @@
           <a:solidFill>
             <a:srgbClr val="1A3558"/>
           </a:solidFill>
-          <a:ln>
-            <a:noFill/>
+          <a:ln w="3810">
+            <a:solidFill>
+              <a:srgbClr val="2E5395"/>
+            </a:solidFill>
           </a:ln>
         </p:spPr>
         <p:style>
@@ -8037,14 +7979,14 @@
       </p:sp>
       <p:sp>
         <p:nvSpPr>
-          <p:cNvPr id="125" name="TextBox 124"/>
+          <p:cNvPr id="120" name="TextBox 119"/>
           <p:cNvSpPr txBox="1"/>
           <p:nvPr/>
         </p:nvSpPr>
         <p:spPr>
           <a:xfrm>
-            <a:off x="11183112" y="7306056"/>
-            <a:ext cx="3383280" cy="146304"/>
+            <a:off x="12006072" y="7205472"/>
+            <a:ext cx="2921508" cy="164592"/>
           </a:xfrm>
           <a:prstGeom prst="rect">
             <a:avLst/>
@@ -8071,14 +8013,14 @@
       </p:sp>
       <p:sp>
         <p:nvSpPr>
-          <p:cNvPr id="126" name="TextBox 125"/>
+          <p:cNvPr id="121" name="TextBox 120"/>
           <p:cNvSpPr txBox="1"/>
           <p:nvPr/>
         </p:nvSpPr>
         <p:spPr>
           <a:xfrm>
-            <a:off x="11183112" y="7452360"/>
-            <a:ext cx="3383280" cy="182880"/>
+            <a:off x="12006072" y="7370064"/>
+            <a:ext cx="2921508" cy="182880"/>
           </a:xfrm>
           <a:prstGeom prst="rect">
             <a:avLst/>
@@ -8105,14 +8047,14 @@
       </p:sp>
       <p:sp>
         <p:nvSpPr>
-          <p:cNvPr id="127" name="Rectangle 126"/>
+          <p:cNvPr id="122" name="Rectangle 121"/>
           <p:cNvSpPr/>
           <p:nvPr/>
         </p:nvSpPr>
         <p:spPr>
           <a:xfrm>
-            <a:off x="14676120" y="7269480"/>
-            <a:ext cx="3474720" cy="402336"/>
+            <a:off x="15073884" y="7168896"/>
+            <a:ext cx="3049524" cy="420624"/>
           </a:xfrm>
           <a:prstGeom prst="rect">
             <a:avLst/>
@@ -8120,8 +8062,10 @@
           <a:solidFill>
             <a:srgbClr val="1A3558"/>
           </a:solidFill>
-          <a:ln>
-            <a:noFill/>
+          <a:ln w="3810">
+            <a:solidFill>
+              <a:srgbClr val="2E5395"/>
+            </a:solidFill>
           </a:ln>
         </p:spPr>
         <p:style>
@@ -8148,14 +8092,14 @@
       </p:sp>
       <p:sp>
         <p:nvSpPr>
-          <p:cNvPr id="128" name="TextBox 127"/>
+          <p:cNvPr id="123" name="TextBox 122"/>
           <p:cNvSpPr txBox="1"/>
           <p:nvPr/>
         </p:nvSpPr>
         <p:spPr>
           <a:xfrm>
-            <a:off x="14749272" y="7306056"/>
-            <a:ext cx="3383280" cy="146304"/>
+            <a:off x="15165324" y="7205472"/>
+            <a:ext cx="2921508" cy="164592"/>
           </a:xfrm>
           <a:prstGeom prst="rect">
             <a:avLst/>
@@ -8182,14 +8126,14 @@
       </p:sp>
       <p:sp>
         <p:nvSpPr>
-          <p:cNvPr id="129" name="TextBox 128"/>
+          <p:cNvPr id="124" name="TextBox 123"/>
           <p:cNvSpPr txBox="1"/>
           <p:nvPr/>
         </p:nvSpPr>
         <p:spPr>
           <a:xfrm>
-            <a:off x="14749272" y="7452360"/>
-            <a:ext cx="3383280" cy="182880"/>
+            <a:off x="15165324" y="7370064"/>
+            <a:ext cx="2921508" cy="182880"/>
           </a:xfrm>
           <a:prstGeom prst="rect">
             <a:avLst/>
@@ -8216,14 +8160,14 @@
       </p:sp>
       <p:sp>
         <p:nvSpPr>
-          <p:cNvPr id="130" name="Rectangle 129"/>
+          <p:cNvPr id="125" name="Rectangle 124"/>
           <p:cNvSpPr/>
           <p:nvPr/>
         </p:nvSpPr>
         <p:spPr>
           <a:xfrm>
-            <a:off x="11109960" y="7726679"/>
-            <a:ext cx="3474720" cy="402336"/>
+            <a:off x="11914632" y="7644383"/>
+            <a:ext cx="3049524" cy="420624"/>
           </a:xfrm>
           <a:prstGeom prst="rect">
             <a:avLst/>
@@ -8231,8 +8175,10 @@
           <a:solidFill>
             <a:srgbClr val="1A3558"/>
           </a:solidFill>
-          <a:ln>
-            <a:noFill/>
+          <a:ln w="3810">
+            <a:solidFill>
+              <a:srgbClr val="2E5395"/>
+            </a:solidFill>
           </a:ln>
         </p:spPr>
         <p:style>
@@ -8259,14 +8205,14 @@
       </p:sp>
       <p:sp>
         <p:nvSpPr>
-          <p:cNvPr id="131" name="TextBox 130"/>
+          <p:cNvPr id="126" name="TextBox 125"/>
           <p:cNvSpPr txBox="1"/>
           <p:nvPr/>
         </p:nvSpPr>
         <p:spPr>
           <a:xfrm>
-            <a:off x="11183112" y="7763255"/>
-            <a:ext cx="3383280" cy="146304"/>
+            <a:off x="12006072" y="7680959"/>
+            <a:ext cx="2921508" cy="164592"/>
           </a:xfrm>
           <a:prstGeom prst="rect">
             <a:avLst/>
@@ -8293,14 +8239,14 @@
       </p:sp>
       <p:sp>
         <p:nvSpPr>
-          <p:cNvPr id="132" name="TextBox 131"/>
+          <p:cNvPr id="127" name="TextBox 126"/>
           <p:cNvSpPr txBox="1"/>
           <p:nvPr/>
         </p:nvSpPr>
         <p:spPr>
           <a:xfrm>
-            <a:off x="11183112" y="7909559"/>
-            <a:ext cx="3383280" cy="182880"/>
+            <a:off x="12006072" y="7845552"/>
+            <a:ext cx="2921508" cy="182880"/>
           </a:xfrm>
           <a:prstGeom prst="rect">
             <a:avLst/>
@@ -8327,14 +8273,14 @@
       </p:sp>
       <p:sp>
         <p:nvSpPr>
-          <p:cNvPr id="133" name="Rectangle 132"/>
+          <p:cNvPr id="128" name="Rectangle 127"/>
           <p:cNvSpPr/>
           <p:nvPr/>
         </p:nvSpPr>
         <p:spPr>
           <a:xfrm>
-            <a:off x="14676120" y="7726679"/>
-            <a:ext cx="3474720" cy="402336"/>
+            <a:off x="15073884" y="7644383"/>
+            <a:ext cx="3049524" cy="420624"/>
           </a:xfrm>
           <a:prstGeom prst="rect">
             <a:avLst/>
@@ -8342,8 +8288,10 @@
           <a:solidFill>
             <a:srgbClr val="1A3558"/>
           </a:solidFill>
-          <a:ln>
-            <a:noFill/>
+          <a:ln w="3810">
+            <a:solidFill>
+              <a:srgbClr val="2E5395"/>
+            </a:solidFill>
           </a:ln>
         </p:spPr>
         <p:style>
@@ -8370,14 +8318,14 @@
       </p:sp>
       <p:sp>
         <p:nvSpPr>
-          <p:cNvPr id="134" name="TextBox 133"/>
+          <p:cNvPr id="129" name="TextBox 128"/>
           <p:cNvSpPr txBox="1"/>
           <p:nvPr/>
         </p:nvSpPr>
         <p:spPr>
           <a:xfrm>
-            <a:off x="14749272" y="7763255"/>
-            <a:ext cx="3383280" cy="146304"/>
+            <a:off x="15165324" y="7680959"/>
+            <a:ext cx="2921508" cy="164592"/>
           </a:xfrm>
           <a:prstGeom prst="rect">
             <a:avLst/>
@@ -8404,14 +8352,14 @@
       </p:sp>
       <p:sp>
         <p:nvSpPr>
-          <p:cNvPr id="135" name="TextBox 134"/>
+          <p:cNvPr id="130" name="TextBox 129"/>
           <p:cNvSpPr txBox="1"/>
           <p:nvPr/>
         </p:nvSpPr>
         <p:spPr>
           <a:xfrm>
-            <a:off x="14749272" y="7909559"/>
-            <a:ext cx="3383280" cy="182880"/>
+            <a:off x="15165324" y="7845552"/>
+            <a:ext cx="2921508" cy="182880"/>
           </a:xfrm>
           <a:prstGeom prst="rect">
             <a:avLst/>
@@ -8438,14 +8386,14 @@
       </p:sp>
       <p:sp>
         <p:nvSpPr>
-          <p:cNvPr id="136" name="Rectangle 135"/>
+          <p:cNvPr id="131" name="Rectangle 130"/>
           <p:cNvSpPr/>
           <p:nvPr/>
         </p:nvSpPr>
         <p:spPr>
           <a:xfrm>
-            <a:off x="11109960" y="8183879"/>
-            <a:ext cx="3474720" cy="402336"/>
+            <a:off x="11914632" y="8119871"/>
+            <a:ext cx="3049524" cy="420624"/>
           </a:xfrm>
           <a:prstGeom prst="rect">
             <a:avLst/>
@@ -8453,8 +8401,10 @@
           <a:solidFill>
             <a:srgbClr val="1A3558"/>
           </a:solidFill>
-          <a:ln>
-            <a:noFill/>
+          <a:ln w="3810">
+            <a:solidFill>
+              <a:srgbClr val="2E5395"/>
+            </a:solidFill>
           </a:ln>
         </p:spPr>
         <p:style>
@@ -8481,14 +8431,14 @@
       </p:sp>
       <p:sp>
         <p:nvSpPr>
-          <p:cNvPr id="137" name="TextBox 136"/>
+          <p:cNvPr id="132" name="TextBox 131"/>
           <p:cNvSpPr txBox="1"/>
           <p:nvPr/>
         </p:nvSpPr>
         <p:spPr>
           <a:xfrm>
-            <a:off x="11183112" y="8220455"/>
-            <a:ext cx="3383280" cy="146304"/>
+            <a:off x="12006072" y="8156447"/>
+            <a:ext cx="2921508" cy="164592"/>
           </a:xfrm>
           <a:prstGeom prst="rect">
             <a:avLst/>
@@ -8515,14 +8465,14 @@
       </p:sp>
       <p:sp>
         <p:nvSpPr>
-          <p:cNvPr id="138" name="TextBox 137"/>
+          <p:cNvPr id="133" name="TextBox 132"/>
           <p:cNvSpPr txBox="1"/>
           <p:nvPr/>
         </p:nvSpPr>
         <p:spPr>
           <a:xfrm>
-            <a:off x="11183112" y="8366759"/>
-            <a:ext cx="3383280" cy="182880"/>
+            <a:off x="12006072" y="8321040"/>
+            <a:ext cx="2921508" cy="182880"/>
           </a:xfrm>
           <a:prstGeom prst="rect">
             <a:avLst/>
@@ -8549,14 +8499,14 @@
       </p:sp>
       <p:sp>
         <p:nvSpPr>
-          <p:cNvPr id="139" name="Rectangle 138"/>
+          <p:cNvPr id="134" name="Rectangle 133"/>
           <p:cNvSpPr/>
           <p:nvPr/>
         </p:nvSpPr>
         <p:spPr>
           <a:xfrm>
-            <a:off x="14676120" y="8183879"/>
-            <a:ext cx="3474720" cy="402336"/>
+            <a:off x="15073884" y="8119871"/>
+            <a:ext cx="3049524" cy="420624"/>
           </a:xfrm>
           <a:prstGeom prst="rect">
             <a:avLst/>
@@ -8564,8 +8514,10 @@
           <a:solidFill>
             <a:srgbClr val="1A3558"/>
           </a:solidFill>
-          <a:ln>
-            <a:noFill/>
+          <a:ln w="3810">
+            <a:solidFill>
+              <a:srgbClr val="2E5395"/>
+            </a:solidFill>
           </a:ln>
         </p:spPr>
         <p:style>
@@ -8592,14 +8544,14 @@
       </p:sp>
       <p:sp>
         <p:nvSpPr>
-          <p:cNvPr id="140" name="TextBox 139"/>
+          <p:cNvPr id="135" name="TextBox 134"/>
           <p:cNvSpPr txBox="1"/>
           <p:nvPr/>
         </p:nvSpPr>
         <p:spPr>
           <a:xfrm>
-            <a:off x="14749272" y="8220455"/>
-            <a:ext cx="3383280" cy="146304"/>
+            <a:off x="15165324" y="8156447"/>
+            <a:ext cx="2921508" cy="164592"/>
           </a:xfrm>
           <a:prstGeom prst="rect">
             <a:avLst/>
@@ -8626,14 +8578,14 @@
       </p:sp>
       <p:sp>
         <p:nvSpPr>
-          <p:cNvPr id="141" name="TextBox 140"/>
+          <p:cNvPr id="136" name="TextBox 135"/>
           <p:cNvSpPr txBox="1"/>
           <p:nvPr/>
         </p:nvSpPr>
         <p:spPr>
           <a:xfrm>
-            <a:off x="14749272" y="8366759"/>
-            <a:ext cx="3383280" cy="182880"/>
+            <a:off x="15165324" y="8321040"/>
+            <a:ext cx="2921508" cy="182880"/>
           </a:xfrm>
           <a:prstGeom prst="rect">
             <a:avLst/>
@@ -8660,57 +8612,14 @@
       </p:sp>
       <p:sp>
         <p:nvSpPr>
-          <p:cNvPr id="142" name="Rectangle 141"/>
-          <p:cNvSpPr/>
-          <p:nvPr/>
-        </p:nvSpPr>
-        <p:spPr>
-          <a:xfrm>
-            <a:off x="0" y="9738360"/>
-            <a:ext cx="18288000" cy="548640"/>
-          </a:xfrm>
-          <a:prstGeom prst="rect">
-            <a:avLst/>
-          </a:prstGeom>
-          <a:solidFill>
-            <a:srgbClr val="091A29"/>
-          </a:solidFill>
-          <a:ln>
-            <a:noFill/>
-          </a:ln>
-        </p:spPr>
-        <p:style>
-          <a:lnRef idx="1">
-            <a:schemeClr val="accent1"/>
-          </a:lnRef>
-          <a:fillRef idx="3">
-            <a:schemeClr val="accent1"/>
-          </a:fillRef>
-          <a:effectRef idx="2">
-            <a:schemeClr val="accent1"/>
-          </a:effectRef>
-          <a:fontRef idx="minor">
-            <a:schemeClr val="lt1"/>
-          </a:fontRef>
-        </p:style>
-        <p:txBody>
-          <a:bodyPr rtlCol="0" anchor="ctr"/>
-          <a:lstStyle/>
-          <a:p>
-            <a:pPr algn="ctr"/>
-          </a:p>
-        </p:txBody>
-      </p:sp>
-      <p:sp>
-        <p:nvSpPr>
-          <p:cNvPr id="143" name="TextBox 142"/>
+          <p:cNvPr id="137" name="TextBox 136"/>
           <p:cNvSpPr txBox="1"/>
           <p:nvPr/>
         </p:nvSpPr>
         <p:spPr>
           <a:xfrm>
-            <a:off x="274320" y="9802368"/>
-            <a:ext cx="5486400" cy="274320"/>
+            <a:off x="274320" y="9838944"/>
+            <a:ext cx="5943600" cy="320040"/>
           </a:xfrm>
           <a:prstGeom prst="rect">
             <a:avLst/>
@@ -8737,14 +8646,14 @@
       </p:sp>
       <p:sp>
         <p:nvSpPr>
-          <p:cNvPr id="144" name="TextBox 143"/>
+          <p:cNvPr id="138" name="TextBox 137"/>
           <p:cNvSpPr txBox="1"/>
           <p:nvPr/>
         </p:nvSpPr>
         <p:spPr>
           <a:xfrm>
-            <a:off x="5943600" y="9802368"/>
-            <a:ext cx="6400800" cy="274320"/>
+            <a:off x="6217920" y="9838944"/>
+            <a:ext cx="5852160" cy="320040"/>
           </a:xfrm>
           <a:prstGeom prst="rect">
             <a:avLst/>
@@ -8759,7 +8668,7 @@
           <a:p>
             <a:pPr algn="ctr"/>
             <a:r>
-              <a:rPr sz="800" b="1" i="0">
+              <a:rPr sz="850" b="1" i="0">
                 <a:solidFill>
                   <a:srgbClr val="FDE499"/>
                 </a:solidFill>
@@ -8771,14 +8680,14 @@
       </p:sp>
       <p:sp>
         <p:nvSpPr>
-          <p:cNvPr id="145" name="TextBox 144"/>
+          <p:cNvPr id="139" name="TextBox 138"/>
           <p:cNvSpPr txBox="1"/>
           <p:nvPr/>
         </p:nvSpPr>
         <p:spPr>
           <a:xfrm>
-            <a:off x="12801600" y="9802368"/>
-            <a:ext cx="5212080" cy="274320"/>
+            <a:off x="12252960" y="9838944"/>
+            <a:ext cx="5852160" cy="320040"/>
           </a:xfrm>
           <a:prstGeom prst="rect">
             <a:avLst/>

</xml_diff>